<commit_message>
Lead the cover with the finding rather than the structural check
Co-Authored-By: Claude Fable 5 <noreply@anthropic.com>
</commit_message>
<xml_diff>
--- a/meeting/SourceDepth_meeting_v5.pptx
+++ b/meeting/SourceDepth_meeting_v5.pptx
@@ -863,7 +863,7 @@
           <a:p>
             <a:r>
               <a:rPr lang="en-US" dirty="0"/>
-              <a:t>이 슬라이드가 오늘의 핵심입니다. 인과 순서상 이미지1은 이미지2를 볼 수 없으므로 경로는 둘뿐입니다. 놀랍게도 질문이 방해 이미지를 읽는 경로만 끊으면 전면 차단과 결과가 소수점까지 같습니다. 반대로 이미지끼리 보는 경로를 끊으면 크게 나빠집니다. 즉 저희가 처음에 세웠던 '정보가 섞여서 나쁘다'는 가설은 틀렸고, 섞이는 것은 오히려 도움이 됩니다.</a:t>
+              <a:t>이 슬라이드가 오늘의 핵심입니다. 왼쪽 박스는 솔직히 말씀드리면 구조상 예상되는 결과입니다. 관련 이미지가 방해보다 앞에 있으면 방해를 볼 수 없으니, 경로가 읽기 하나로 강제됩니다. 저희 구현이 정확하다는 검증으로 봐주시면 됩니다. 진짜 발견은 오른쪽입니다. 이미지끼리 보는 경로를 끊으면 크게 나빠집니다. 방해 이미지가 관련 이미지를 보고 맥락화되면 오히려 덜 해롭고, 고립시키면 더 도드라져서 침입한다는 뜻입니다. 그리고 순서를 뒤집으면 관련 이미지가 방해를 볼 수 있게 되어 표현 오염 경로가 실제로 생깁니다. 그 배치에서 다시 재고 있습니다.</a:t>
             </a:r>
             <a:endParaRPr lang="en-US" dirty="0"/>
           </a:p>
@@ -2063,7 +2063,7 @@
                 <a:ea typeface="Arial" pitchFamily="34" charset="-122"/>
                 <a:cs typeface="Arial" pitchFamily="34" charset="-120"/>
               </a:rPr>
-              <a:t>원인을 특정했다</a:t>
+              <a:t>원인이 예상과 반대였다</a:t>
             </a:r>
             <a:endParaRPr lang="en-US" sz="1500" dirty="0"/>
           </a:p>
@@ -2105,7 +2105,7 @@
                 <a:ea typeface="Arial" pitchFamily="34" charset="-122"/>
                 <a:cs typeface="Arial" pitchFamily="34" charset="-120"/>
               </a:rPr>
-              <a:t>해악은 '질문 → 무관이미지' 읽기 경로</a:t>
+              <a:t>이미지 간 혼합을 끊으면 오히려</a:t>
             </a:r>
             <a:endParaRPr lang="en-US" sz="1200" dirty="0"/>
           </a:p>
@@ -2125,7 +2125,7 @@
                 <a:ea typeface="Arial" pitchFamily="34" charset="-122"/>
                 <a:cs typeface="Arial" pitchFamily="34" charset="-120"/>
               </a:rPr>
-              <a:t>하나로만 흐른다. 이미지 간 혼합을 끊으면</a:t>
+              <a:t>−0.29 / −0.42로 크게 나빠진다.</a:t>
             </a:r>
             <a:endParaRPr lang="en-US" sz="1200" dirty="0"/>
           </a:p>
@@ -2145,7 +2145,7 @@
                 <a:ea typeface="Arial" pitchFamily="34" charset="-122"/>
                 <a:cs typeface="Arial" pitchFamily="34" charset="-120"/>
               </a:rPr>
-              <a:t>오히려 −0.29로 크게 나빠진다</a:t>
+              <a:t>해악은 혼합이 아니라 읽기 단계에 있다</a:t>
             </a:r>
             <a:endParaRPr lang="en-US" sz="1200" dirty="0"/>
           </a:p>
@@ -2184,7 +2184,7 @@
                 <a:ea typeface="Arial" pitchFamily="34" charset="-122"/>
                 <a:cs typeface="Arial" pitchFamily="34" charset="-120"/>
               </a:rPr>
-              <a:t>읽기차단 ≡ 전면차단, CI [0, 0]</a:t>
+              <a:t>설계 가설을 우리 손으로 반증</a:t>
             </a:r>
             <a:endParaRPr lang="en-US" sz="1050" dirty="0"/>
           </a:p>
@@ -9182,7 +9182,7 @@
                 <a:ea typeface="Arial" pitchFamily="34" charset="-122"/>
                 <a:cs typeface="Arial" pitchFamily="34" charset="-120"/>
               </a:rPr>
-              <a:t>① 읽기 경로 차단 = 전면 차단, 소수점까지 동일</a:t>
+              <a:t>① 이 배치에서는 해악의 경로가 '읽기' 하나뿐</a:t>
             </a:r>
             <a:endParaRPr lang="en-US" sz="1300" dirty="0"/>
           </a:p>
@@ -9224,7 +9224,7 @@
                 <a:ea typeface="Arial" pitchFamily="34" charset="-122"/>
                 <a:cs typeface="Arial" pitchFamily="34" charset="-120"/>
               </a:rPr>
-              <a:t>차이 0.0000, 95% CI [0, 0].</a:t>
+              <a:t>읽기 차단 = 전면 차단, 차이 0.0000 (CI [0,0]).</a:t>
             </a:r>
             <a:endParaRPr lang="en-US" sz="1100" dirty="0"/>
           </a:p>
@@ -9244,7 +9244,7 @@
                 <a:ea typeface="Arial" pitchFamily="34" charset="-122"/>
                 <a:cs typeface="Arial" pitchFamily="34" charset="-120"/>
               </a:rPr>
-              <a:t>방해 이미지의 영향은 '질문 토큰이 그것을 읽는'</a:t>
+              <a:t>관련 이미지가 방해보다 앞이라 방해를 볼 수 없기 때문 —</a:t>
             </a:r>
             <a:endParaRPr lang="en-US" sz="1100" dirty="0"/>
           </a:p>
@@ -9264,7 +9264,7 @@
                 <a:ea typeface="Arial" pitchFamily="34" charset="-122"/>
                 <a:cs typeface="Arial" pitchFamily="34" charset="-120"/>
               </a:rPr>
-              <a:t>경로 하나로만 흐릅니다. 다른 채널이 없습니다.</a:t>
+              <a:t>구조상 예상되며, 구현 정확성 검증을 겸합니다.</a:t>
             </a:r>
             <a:endParaRPr lang="en-US" sz="1100" dirty="0"/>
           </a:p>
@@ -9330,7 +9330,7 @@
                 <a:ea typeface="Arial" pitchFamily="34" charset="-122"/>
                 <a:cs typeface="Arial" pitchFamily="34" charset="-120"/>
               </a:rPr>
-              <a:t>② 이미지 간 혼합을 끊으면 오히려 크게 나빠짐</a:t>
+              <a:t>② 예상 밖 — 이미지 간 혼합을 끊으면 크게 나빠짐</a:t>
             </a:r>
             <a:endParaRPr lang="en-US" sz="1300" dirty="0"/>
           </a:p>
@@ -9392,7 +9392,7 @@
                 <a:ea typeface="Arial" pitchFamily="34" charset="-122"/>
                 <a:cs typeface="Arial" pitchFamily="34" charset="-120"/>
               </a:rPr>
-              <a:t>이미지끼리 보는 것은 도움이 됩니다.</a:t>
+              <a:t>방해가 관련 이미지를 보고 맥락화되면 오히려 덜 해롭습니다.</a:t>
             </a:r>
             <a:endParaRPr lang="en-US" sz="1100" dirty="0"/>
           </a:p>
@@ -9412,7 +9412,7 @@
                 <a:ea typeface="Arial" pitchFamily="34" charset="-122"/>
                 <a:cs typeface="Arial" pitchFamily="34" charset="-120"/>
               </a:rPr>
-              <a:t>설계 가설과 정반대 방향입니다.</a:t>
+              <a:t>고립시키면 더 도드라져 침입합니다. 이것이 실제 발견입니다.</a:t>
             </a:r>
             <a:endParaRPr lang="en-US" sz="1100" dirty="0"/>
           </a:p>
@@ -9490,7 +9490,7 @@
                 <a:ea typeface="Arial" pitchFamily="34" charset="-122"/>
                 <a:cs typeface="Arial" pitchFamily="34" charset="-120"/>
               </a:rPr>
-              <a:t>n=300 · AUC · 4D mask의 (질의 행 × 키 열) 사각형 단위 개입. 읽기차단 ≡ 전면차단은 구현 정확성 검증도 겸함</a:t>
+              <a:t>n=300 · AUC · 4D mask의 (질의 행 × 키 열) 사각형 단위 개입. 순서를 뒤집으면 관련 이미지가 방해를 볼 수 있어 표현 오염 경로가 생김 — 현재 측정 중</a:t>
             </a:r>
             <a:endParaRPr lang="en-US" sz="1000" dirty="0"/>
           </a:p>

</xml_diff>

<commit_message>
Add 7B controller results: it works best where it is least needed
7B's counterfactual controller hits 0.93-0.95, far above 3B's 0.73, because the
signal is cleaner there — removing an irrelevant image barely moves a 7B answer
while removing the relevant one moves it a lot, so the two distributions separate.
But 7B's break-even is 0.97, since there is almost no damage to recover, and the
net stays at about +1.9pp.

That completes the two-regime picture the deck now states plainly: small models
have large damage, a moderate controller and a large net gain; large models have
an excellent controller and nothing worth fixing. The method's value sits in the
small-model, many-distractor regime.

Co-Authored-By: Claude Fable 5 <noreply@anthropic.com>
</commit_message>
<xml_diff>
--- a/meeting/SourceDepth_meeting_v5.pptx
+++ b/meeting/SourceDepth_meeting_v5.pptx
@@ -14272,7 +14272,64 @@
                 <a:gridCol w="1866900"/>
                 <a:gridCol w="1866900"/>
               </a:tblGrid>
-              <a:tr h="411480">
+              <a:tr h="384048">
+                <a:tc>
+                  <a:txBody>
+                    <a:bodyPr/>
+                    <a:lstStyle/>
+                    <a:p>
+                      <a:pPr algn="ctr" indent="0" marL="0">
+                        <a:buNone/>
+                      </a:pPr>
+                      <a:endParaRPr lang="en-US" sz="1150" dirty="0">
+                        <a:latin typeface="Arial" charset="0"/>
+                        <a:ea typeface="Arial" charset="0"/>
+                        <a:cs typeface="Arial" charset="0"/>
+                      </a:endParaRPr>
+                    </a:p>
+                  </a:txBody>
+                  <a:tcPr marL="91440" marR="91440" marT="45720" marB="45720" anchor="ctr">
+                    <a:lnL w="9525" cap="flat" cmpd="sng" algn="ctr">
+                      <a:solidFill>
+                        <a:srgbClr val="E2E8F0"/>
+                      </a:solidFill>
+                      <a:prstDash val="solid"/>
+                      <a:round/>
+                      <a:headEnd type="none" w="med" len="med"/>
+                      <a:tailEnd type="none" w="med" len="med"/>
+                    </a:lnL>
+                    <a:lnR w="9525" cap="flat" cmpd="sng" algn="ctr">
+                      <a:solidFill>
+                        <a:srgbClr val="E2E8F0"/>
+                      </a:solidFill>
+                      <a:prstDash val="solid"/>
+                      <a:round/>
+                      <a:headEnd type="none" w="med" len="med"/>
+                      <a:tailEnd type="none" w="med" len="med"/>
+                    </a:lnR>
+                    <a:lnT w="9525" cap="flat" cmpd="sng" algn="ctr">
+                      <a:solidFill>
+                        <a:srgbClr val="E2E8F0"/>
+                      </a:solidFill>
+                      <a:prstDash val="solid"/>
+                      <a:round/>
+                      <a:headEnd type="none" w="med" len="med"/>
+                      <a:tailEnd type="none" w="med" len="med"/>
+                    </a:lnT>
+                    <a:lnB w="9525" cap="flat" cmpd="sng" algn="ctr">
+                      <a:solidFill>
+                        <a:srgbClr val="E2E8F0"/>
+                      </a:solidFill>
+                      <a:prstDash val="solid"/>
+                      <a:round/>
+                      <a:headEnd type="none" w="med" len="med"/>
+                      <a:tailEnd type="none" w="med" len="med"/>
+                    </a:lnB>
+                    <a:solidFill>
+                      <a:srgbClr val="1F3B57"/>
+                    </a:solidFill>
+                  </a:tcPr>
+                </a:tc>
                 <a:tc>
                   <a:txBody>
                     <a:bodyPr/>
@@ -14358,75 +14415,7 @@
                           <a:ea typeface="Arial" pitchFamily="34" charset="-122"/>
                           <a:cs typeface="Arial" pitchFamily="34" charset="-120"/>
                         </a:rPr>
-                        <a:t>컨트롤러 정확도</a:t>
-                      </a:r>
-                      <a:endParaRPr lang="en-US" sz="1150" dirty="0">
-                        <a:latin typeface="Arial" charset="0"/>
-                        <a:ea typeface="Arial" charset="0"/>
-                        <a:cs typeface="Arial" charset="0"/>
-                      </a:endParaRPr>
-                    </a:p>
-                  </a:txBody>
-                  <a:tcPr marL="91440" marR="91440" marT="45720" marB="45720" anchor="ctr">
-                    <a:lnL w="9525" cap="flat" cmpd="sng" algn="ctr">
-                      <a:solidFill>
-                        <a:srgbClr val="E2E8F0"/>
-                      </a:solidFill>
-                      <a:prstDash val="solid"/>
-                      <a:round/>
-                      <a:headEnd type="none" w="med" len="med"/>
-                      <a:tailEnd type="none" w="med" len="med"/>
-                    </a:lnL>
-                    <a:lnR w="9525" cap="flat" cmpd="sng" algn="ctr">
-                      <a:solidFill>
-                        <a:srgbClr val="E2E8F0"/>
-                      </a:solidFill>
-                      <a:prstDash val="solid"/>
-                      <a:round/>
-                      <a:headEnd type="none" w="med" len="med"/>
-                      <a:tailEnd type="none" w="med" len="med"/>
-                    </a:lnR>
-                    <a:lnT w="9525" cap="flat" cmpd="sng" algn="ctr">
-                      <a:solidFill>
-                        <a:srgbClr val="E2E8F0"/>
-                      </a:solidFill>
-                      <a:prstDash val="solid"/>
-                      <a:round/>
-                      <a:headEnd type="none" w="med" len="med"/>
-                      <a:tailEnd type="none" w="med" len="med"/>
-                    </a:lnT>
-                    <a:lnB w="9525" cap="flat" cmpd="sng" algn="ctr">
-                      <a:solidFill>
-                        <a:srgbClr val="E2E8F0"/>
-                      </a:solidFill>
-                      <a:prstDash val="solid"/>
-                      <a:round/>
-                      <a:headEnd type="none" w="med" len="med"/>
-                      <a:tailEnd type="none" w="med" len="med"/>
-                    </a:lnB>
-                    <a:solidFill>
-                      <a:srgbClr val="1F3B57"/>
-                    </a:solidFill>
-                  </a:tcPr>
-                </a:tc>
-                <a:tc>
-                  <a:txBody>
-                    <a:bodyPr/>
-                    <a:lstStyle/>
-                    <a:p>
-                      <a:pPr algn="ctr" indent="0" marL="0">
-                        <a:buNone/>
-                      </a:pPr>
-                      <a:r>
-                        <a:rPr lang="en-US" sz="1150" b="1" dirty="0">
-                          <a:solidFill>
-                            <a:srgbClr val="FFFFFF"/>
-                          </a:solidFill>
-                          <a:latin typeface="Arial" pitchFamily="34" charset="0"/>
-                          <a:ea typeface="Arial" pitchFamily="34" charset="-122"/>
-                          <a:cs typeface="Arial" pitchFamily="34" charset="-120"/>
-                        </a:rPr>
-                        <a:t>무작위 기준</a:t>
+                        <a:t>컨트롤러</a:t>
                       </a:r>
                       <a:endParaRPr lang="en-US" sz="1150" dirty="0">
                         <a:latin typeface="Arial" charset="0"/>
@@ -14682,7 +14671,7 @@
                   </a:tcPr>
                 </a:tc>
               </a:tr>
-              <a:tr h="384048">
+              <a:tr h="347472">
                 <a:tc>
                   <a:txBody>
                     <a:bodyPr/>
@@ -14693,6 +14682,74 @@
                       </a:pPr>
                       <a:r>
                         <a:rPr lang="en-US" sz="1150" b="1" dirty="0">
+                          <a:solidFill>
+                            <a:srgbClr val="1F3B57"/>
+                          </a:solidFill>
+                          <a:latin typeface="Arial" pitchFamily="34" charset="0"/>
+                          <a:ea typeface="Arial" pitchFamily="34" charset="-122"/>
+                          <a:cs typeface="Arial" pitchFamily="34" charset="-120"/>
+                        </a:rPr>
+                        <a:t>3B</a:t>
+                      </a:r>
+                      <a:endParaRPr lang="en-US" sz="1150" dirty="0">
+                        <a:latin typeface="Arial" charset="0"/>
+                        <a:ea typeface="Arial" charset="0"/>
+                        <a:cs typeface="Arial" charset="0"/>
+                      </a:endParaRPr>
+                    </a:p>
+                  </a:txBody>
+                  <a:tcPr marL="91440" marR="91440" marT="45720" marB="45720" anchor="ctr">
+                    <a:lnL w="9525" cap="flat" cmpd="sng" algn="ctr">
+                      <a:solidFill>
+                        <a:srgbClr val="E2E8F0"/>
+                      </a:solidFill>
+                      <a:prstDash val="solid"/>
+                      <a:round/>
+                      <a:headEnd type="none" w="med" len="med"/>
+                      <a:tailEnd type="none" w="med" len="med"/>
+                    </a:lnL>
+                    <a:lnR w="9525" cap="flat" cmpd="sng" algn="ctr">
+                      <a:solidFill>
+                        <a:srgbClr val="E2E8F0"/>
+                      </a:solidFill>
+                      <a:prstDash val="solid"/>
+                      <a:round/>
+                      <a:headEnd type="none" w="med" len="med"/>
+                      <a:tailEnd type="none" w="med" len="med"/>
+                    </a:lnR>
+                    <a:lnT w="9525" cap="flat" cmpd="sng" algn="ctr">
+                      <a:solidFill>
+                        <a:srgbClr val="E2E8F0"/>
+                      </a:solidFill>
+                      <a:prstDash val="solid"/>
+                      <a:round/>
+                      <a:headEnd type="none" w="med" len="med"/>
+                      <a:tailEnd type="none" w="med" len="med"/>
+                    </a:lnT>
+                    <a:lnB w="9525" cap="flat" cmpd="sng" algn="ctr">
+                      <a:solidFill>
+                        <a:srgbClr val="E2E8F0"/>
+                      </a:solidFill>
+                      <a:prstDash val="solid"/>
+                      <a:round/>
+                      <a:headEnd type="none" w="med" len="med"/>
+                      <a:tailEnd type="none" w="med" len="med"/>
+                    </a:lnB>
+                    <a:solidFill>
+                      <a:srgbClr val="FFFFFF"/>
+                    </a:solidFill>
+                  </a:tcPr>
+                </a:tc>
+                <a:tc>
+                  <a:txBody>
+                    <a:bodyPr/>
+                    <a:lstStyle/>
+                    <a:p>
+                      <a:pPr algn="ctr" indent="0" marL="0">
+                        <a:buNone/>
+                      </a:pPr>
+                      <a:r>
+                        <a:rPr lang="en-US" sz="1150" dirty="0">
                           <a:solidFill>
                             <a:srgbClr val="1F3B57"/>
                           </a:solidFill>
@@ -14830,74 +14887,6 @@
                       <a:r>
                         <a:rPr lang="en-US" sz="1150" dirty="0">
                           <a:solidFill>
-                            <a:srgbClr val="1F3B57"/>
-                          </a:solidFill>
-                          <a:latin typeface="Arial" pitchFamily="34" charset="0"/>
-                          <a:ea typeface="Arial" pitchFamily="34" charset="-122"/>
-                          <a:cs typeface="Arial" pitchFamily="34" charset="-120"/>
-                        </a:rPr>
-                        <a:t>0.500</a:t>
-                      </a:r>
-                      <a:endParaRPr lang="en-US" sz="1150" dirty="0">
-                        <a:latin typeface="Arial" charset="0"/>
-                        <a:ea typeface="Arial" charset="0"/>
-                        <a:cs typeface="Arial" charset="0"/>
-                      </a:endParaRPr>
-                    </a:p>
-                  </a:txBody>
-                  <a:tcPr marL="91440" marR="91440" marT="45720" marB="45720" anchor="ctr">
-                    <a:lnL w="9525" cap="flat" cmpd="sng" algn="ctr">
-                      <a:solidFill>
-                        <a:srgbClr val="E2E8F0"/>
-                      </a:solidFill>
-                      <a:prstDash val="solid"/>
-                      <a:round/>
-                      <a:headEnd type="none" w="med" len="med"/>
-                      <a:tailEnd type="none" w="med" len="med"/>
-                    </a:lnL>
-                    <a:lnR w="9525" cap="flat" cmpd="sng" algn="ctr">
-                      <a:solidFill>
-                        <a:srgbClr val="E2E8F0"/>
-                      </a:solidFill>
-                      <a:prstDash val="solid"/>
-                      <a:round/>
-                      <a:headEnd type="none" w="med" len="med"/>
-                      <a:tailEnd type="none" w="med" len="med"/>
-                    </a:lnR>
-                    <a:lnT w="9525" cap="flat" cmpd="sng" algn="ctr">
-                      <a:solidFill>
-                        <a:srgbClr val="E2E8F0"/>
-                      </a:solidFill>
-                      <a:prstDash val="solid"/>
-                      <a:round/>
-                      <a:headEnd type="none" w="med" len="med"/>
-                      <a:tailEnd type="none" w="med" len="med"/>
-                    </a:lnT>
-                    <a:lnB w="9525" cap="flat" cmpd="sng" algn="ctr">
-                      <a:solidFill>
-                        <a:srgbClr val="E2E8F0"/>
-                      </a:solidFill>
-                      <a:prstDash val="solid"/>
-                      <a:round/>
-                      <a:headEnd type="none" w="med" len="med"/>
-                      <a:tailEnd type="none" w="med" len="med"/>
-                    </a:lnB>
-                    <a:solidFill>
-                      <a:srgbClr val="FFFFFF"/>
-                    </a:solidFill>
-                  </a:tcPr>
-                </a:tc>
-                <a:tc>
-                  <a:txBody>
-                    <a:bodyPr/>
-                    <a:lstStyle/>
-                    <a:p>
-                      <a:pPr algn="ctr" indent="0" marL="0">
-                        <a:buNone/>
-                      </a:pPr>
-                      <a:r>
-                        <a:rPr lang="en-US" sz="1150" dirty="0">
-                          <a:solidFill>
                             <a:srgbClr val="D62728"/>
                           </a:solidFill>
                           <a:latin typeface="Arial" pitchFamily="34" charset="0"/>
@@ -15092,7 +15081,64 @@
                   </a:tcPr>
                 </a:tc>
               </a:tr>
-              <a:tr h="384048">
+              <a:tr h="347472">
+                <a:tc>
+                  <a:txBody>
+                    <a:bodyPr/>
+                    <a:lstStyle/>
+                    <a:p>
+                      <a:pPr algn="ctr" indent="0" marL="0">
+                        <a:buNone/>
+                      </a:pPr>
+                      <a:endParaRPr lang="en-US" sz="1150" dirty="0">
+                        <a:latin typeface="Arial" charset="0"/>
+                        <a:ea typeface="Arial" charset="0"/>
+                        <a:cs typeface="Arial" charset="0"/>
+                      </a:endParaRPr>
+                    </a:p>
+                  </a:txBody>
+                  <a:tcPr marL="91440" marR="91440" marT="45720" marB="45720" anchor="ctr">
+                    <a:lnL w="9525" cap="flat" cmpd="sng" algn="ctr">
+                      <a:solidFill>
+                        <a:srgbClr val="E2E8F0"/>
+                      </a:solidFill>
+                      <a:prstDash val="solid"/>
+                      <a:round/>
+                      <a:headEnd type="none" w="med" len="med"/>
+                      <a:tailEnd type="none" w="med" len="med"/>
+                    </a:lnL>
+                    <a:lnR w="9525" cap="flat" cmpd="sng" algn="ctr">
+                      <a:solidFill>
+                        <a:srgbClr val="E2E8F0"/>
+                      </a:solidFill>
+                      <a:prstDash val="solid"/>
+                      <a:round/>
+                      <a:headEnd type="none" w="med" len="med"/>
+                      <a:tailEnd type="none" w="med" len="med"/>
+                    </a:lnR>
+                    <a:lnT w="9525" cap="flat" cmpd="sng" algn="ctr">
+                      <a:solidFill>
+                        <a:srgbClr val="E2E8F0"/>
+                      </a:solidFill>
+                      <a:prstDash val="solid"/>
+                      <a:round/>
+                      <a:headEnd type="none" w="med" len="med"/>
+                      <a:tailEnd type="none" w="med" len="med"/>
+                    </a:lnT>
+                    <a:lnB w="9525" cap="flat" cmpd="sng" algn="ctr">
+                      <a:solidFill>
+                        <a:srgbClr val="E2E8F0"/>
+                      </a:solidFill>
+                      <a:prstDash val="solid"/>
+                      <a:round/>
+                      <a:headEnd type="none" w="med" len="med"/>
+                      <a:tailEnd type="none" w="med" len="med"/>
+                    </a:lnB>
+                    <a:solidFill>
+                      <a:srgbClr val="FFFFFF"/>
+                    </a:solidFill>
+                  </a:tcPr>
+                </a:tc>
                 <a:tc>
                   <a:txBody>
                     <a:bodyPr/>
@@ -15102,7 +15148,7 @@
                         <a:buNone/>
                       </a:pPr>
                       <a:r>
-                        <a:rPr lang="en-US" sz="1150" b="1" dirty="0">
+                        <a:rPr lang="en-US" sz="1150" dirty="0">
                           <a:solidFill>
                             <a:srgbClr val="1F3B57"/>
                           </a:solidFill>
@@ -15246,74 +15292,6 @@
                           <a:ea typeface="Arial" pitchFamily="34" charset="-122"/>
                           <a:cs typeface="Arial" pitchFamily="34" charset="-120"/>
                         </a:rPr>
-                        <a:t>0.333</a:t>
-                      </a:r>
-                      <a:endParaRPr lang="en-US" sz="1150" dirty="0">
-                        <a:latin typeface="Arial" charset="0"/>
-                        <a:ea typeface="Arial" charset="0"/>
-                        <a:cs typeface="Arial" charset="0"/>
-                      </a:endParaRPr>
-                    </a:p>
-                  </a:txBody>
-                  <a:tcPr marL="91440" marR="91440" marT="45720" marB="45720" anchor="ctr">
-                    <a:lnL w="9525" cap="flat" cmpd="sng" algn="ctr">
-                      <a:solidFill>
-                        <a:srgbClr val="E2E8F0"/>
-                      </a:solidFill>
-                      <a:prstDash val="solid"/>
-                      <a:round/>
-                      <a:headEnd type="none" w="med" len="med"/>
-                      <a:tailEnd type="none" w="med" len="med"/>
-                    </a:lnL>
-                    <a:lnR w="9525" cap="flat" cmpd="sng" algn="ctr">
-                      <a:solidFill>
-                        <a:srgbClr val="E2E8F0"/>
-                      </a:solidFill>
-                      <a:prstDash val="solid"/>
-                      <a:round/>
-                      <a:headEnd type="none" w="med" len="med"/>
-                      <a:tailEnd type="none" w="med" len="med"/>
-                    </a:lnR>
-                    <a:lnT w="9525" cap="flat" cmpd="sng" algn="ctr">
-                      <a:solidFill>
-                        <a:srgbClr val="E2E8F0"/>
-                      </a:solidFill>
-                      <a:prstDash val="solid"/>
-                      <a:round/>
-                      <a:headEnd type="none" w="med" len="med"/>
-                      <a:tailEnd type="none" w="med" len="med"/>
-                    </a:lnT>
-                    <a:lnB w="9525" cap="flat" cmpd="sng" algn="ctr">
-                      <a:solidFill>
-                        <a:srgbClr val="E2E8F0"/>
-                      </a:solidFill>
-                      <a:prstDash val="solid"/>
-                      <a:round/>
-                      <a:headEnd type="none" w="med" len="med"/>
-                      <a:tailEnd type="none" w="med" len="med"/>
-                    </a:lnB>
-                    <a:solidFill>
-                      <a:srgbClr val="FFFFFF"/>
-                    </a:solidFill>
-                  </a:tcPr>
-                </a:tc>
-                <a:tc>
-                  <a:txBody>
-                    <a:bodyPr/>
-                    <a:lstStyle/>
-                    <a:p>
-                      <a:pPr algn="ctr" indent="0" marL="0">
-                        <a:buNone/>
-                      </a:pPr>
-                      <a:r>
-                        <a:rPr lang="en-US" sz="1150" dirty="0">
-                          <a:solidFill>
-                            <a:srgbClr val="1F3B57"/>
-                          </a:solidFill>
-                          <a:latin typeface="Arial" pitchFamily="34" charset="0"/>
-                          <a:ea typeface="Arial" pitchFamily="34" charset="-122"/>
-                          <a:cs typeface="Arial" pitchFamily="34" charset="-120"/>
-                        </a:rPr>
                         <a:t>0.661</a:t>
                       </a:r>
                       <a:endParaRPr lang="en-US" sz="1150" dirty="0">
@@ -15502,7 +15480,64 @@
                   </a:tcPr>
                 </a:tc>
               </a:tr>
-              <a:tr h="420624">
+              <a:tr h="384048">
+                <a:tc>
+                  <a:txBody>
+                    <a:bodyPr/>
+                    <a:lstStyle/>
+                    <a:p>
+                      <a:pPr algn="ctr" indent="0" marL="0">
+                        <a:buNone/>
+                      </a:pPr>
+                      <a:endParaRPr lang="en-US" sz="1150" dirty="0">
+                        <a:latin typeface="Arial" charset="0"/>
+                        <a:ea typeface="Arial" charset="0"/>
+                        <a:cs typeface="Arial" charset="0"/>
+                      </a:endParaRPr>
+                    </a:p>
+                  </a:txBody>
+                  <a:tcPr marL="91440" marR="91440" marT="45720" marB="45720" anchor="ctr">
+                    <a:lnL w="9525" cap="flat" cmpd="sng" algn="ctr">
+                      <a:solidFill>
+                        <a:srgbClr val="E2E8F0"/>
+                      </a:solidFill>
+                      <a:prstDash val="solid"/>
+                      <a:round/>
+                      <a:headEnd type="none" w="med" len="med"/>
+                      <a:tailEnd type="none" w="med" len="med"/>
+                    </a:lnL>
+                    <a:lnR w="9525" cap="flat" cmpd="sng" algn="ctr">
+                      <a:solidFill>
+                        <a:srgbClr val="E2E8F0"/>
+                      </a:solidFill>
+                      <a:prstDash val="solid"/>
+                      <a:round/>
+                      <a:headEnd type="none" w="med" len="med"/>
+                      <a:tailEnd type="none" w="med" len="med"/>
+                    </a:lnR>
+                    <a:lnT w="9525" cap="flat" cmpd="sng" algn="ctr">
+                      <a:solidFill>
+                        <a:srgbClr val="E2E8F0"/>
+                      </a:solidFill>
+                      <a:prstDash val="solid"/>
+                      <a:round/>
+                      <a:headEnd type="none" w="med" len="med"/>
+                      <a:tailEnd type="none" w="med" len="med"/>
+                    </a:lnT>
+                    <a:lnB w="9525" cap="flat" cmpd="sng" algn="ctr">
+                      <a:solidFill>
+                        <a:srgbClr val="E2E8F0"/>
+                      </a:solidFill>
+                      <a:prstDash val="solid"/>
+                      <a:round/>
+                      <a:headEnd type="none" w="med" len="med"/>
+                      <a:tailEnd type="none" w="med" len="med"/>
+                    </a:lnB>
+                    <a:solidFill>
+                      <a:srgbClr val="FFFFFF"/>
+                    </a:solidFill>
+                  </a:tcPr>
+                </a:tc>
                 <a:tc>
                   <a:txBody>
                     <a:bodyPr/>
@@ -15512,7 +15547,7 @@
                         <a:buNone/>
                       </a:pPr>
                       <a:r>
-                        <a:rPr lang="en-US" sz="1150" b="1" dirty="0">
+                        <a:rPr lang="en-US" sz="1150" dirty="0">
                           <a:solidFill>
                             <a:srgbClr val="1F3B57"/>
                           </a:solidFill>
@@ -15648,74 +15683,6 @@
                         <a:buNone/>
                       </a:pPr>
                       <a:r>
-                        <a:rPr lang="en-US" sz="1150" dirty="0">
-                          <a:solidFill>
-                            <a:srgbClr val="1F3B57"/>
-                          </a:solidFill>
-                          <a:latin typeface="Arial" pitchFamily="34" charset="0"/>
-                          <a:ea typeface="Arial" pitchFamily="34" charset="-122"/>
-                          <a:cs typeface="Arial" pitchFamily="34" charset="-120"/>
-                        </a:rPr>
-                        <a:t>0.250</a:t>
-                      </a:r>
-                      <a:endParaRPr lang="en-US" sz="1150" dirty="0">
-                        <a:latin typeface="Arial" charset="0"/>
-                        <a:ea typeface="Arial" charset="0"/>
-                        <a:cs typeface="Arial" charset="0"/>
-                      </a:endParaRPr>
-                    </a:p>
-                  </a:txBody>
-                  <a:tcPr marL="91440" marR="91440" marT="45720" marB="45720" anchor="ctr">
-                    <a:lnL w="9525" cap="flat" cmpd="sng" algn="ctr">
-                      <a:solidFill>
-                        <a:srgbClr val="E2E8F0"/>
-                      </a:solidFill>
-                      <a:prstDash val="solid"/>
-                      <a:round/>
-                      <a:headEnd type="none" w="med" len="med"/>
-                      <a:tailEnd type="none" w="med" len="med"/>
-                    </a:lnL>
-                    <a:lnR w="9525" cap="flat" cmpd="sng" algn="ctr">
-                      <a:solidFill>
-                        <a:srgbClr val="E2E8F0"/>
-                      </a:solidFill>
-                      <a:prstDash val="solid"/>
-                      <a:round/>
-                      <a:headEnd type="none" w="med" len="med"/>
-                      <a:tailEnd type="none" w="med" len="med"/>
-                    </a:lnR>
-                    <a:lnT w="9525" cap="flat" cmpd="sng" algn="ctr">
-                      <a:solidFill>
-                        <a:srgbClr val="E2E8F0"/>
-                      </a:solidFill>
-                      <a:prstDash val="solid"/>
-                      <a:round/>
-                      <a:headEnd type="none" w="med" len="med"/>
-                      <a:tailEnd type="none" w="med" len="med"/>
-                    </a:lnT>
-                    <a:lnB w="9525" cap="flat" cmpd="sng" algn="ctr">
-                      <a:solidFill>
-                        <a:srgbClr val="E2E8F0"/>
-                      </a:solidFill>
-                      <a:prstDash val="solid"/>
-                      <a:round/>
-                      <a:headEnd type="none" w="med" len="med"/>
-                      <a:tailEnd type="none" w="med" len="med"/>
-                    </a:lnB>
-                    <a:solidFill>
-                      <a:srgbClr val="FFFFFF"/>
-                    </a:solidFill>
-                  </a:tcPr>
-                </a:tc>
-                <a:tc>
-                  <a:txBody>
-                    <a:bodyPr/>
-                    <a:lstStyle/>
-                    <a:p>
-                      <a:pPr algn="ctr" indent="0" marL="0">
-                        <a:buNone/>
-                      </a:pPr>
-                      <a:r>
                         <a:rPr lang="en-US" sz="1150" b="1" dirty="0">
                           <a:solidFill>
                             <a:srgbClr val="2E8B57"/>
@@ -15912,6 +15879,815 @@
                   </a:tcPr>
                 </a:tc>
               </a:tr>
+              <a:tr h="365760">
+                <a:tc>
+                  <a:txBody>
+                    <a:bodyPr/>
+                    <a:lstStyle/>
+                    <a:p>
+                      <a:pPr algn="ctr" indent="0" marL="0">
+                        <a:buNone/>
+                      </a:pPr>
+                      <a:r>
+                        <a:rPr lang="en-US" sz="1150" b="1" dirty="0">
+                          <a:solidFill>
+                            <a:srgbClr val="1F3B57"/>
+                          </a:solidFill>
+                          <a:latin typeface="Arial" pitchFamily="34" charset="0"/>
+                          <a:ea typeface="Arial" pitchFamily="34" charset="-122"/>
+                          <a:cs typeface="Arial" pitchFamily="34" charset="-120"/>
+                        </a:rPr>
+                        <a:t>7B</a:t>
+                      </a:r>
+                      <a:endParaRPr lang="en-US" sz="1150" dirty="0">
+                        <a:latin typeface="Arial" charset="0"/>
+                        <a:ea typeface="Arial" charset="0"/>
+                        <a:cs typeface="Arial" charset="0"/>
+                      </a:endParaRPr>
+                    </a:p>
+                  </a:txBody>
+                  <a:tcPr marL="91440" marR="91440" marT="45720" marB="45720" anchor="ctr">
+                    <a:lnL w="9525" cap="flat" cmpd="sng" algn="ctr">
+                      <a:solidFill>
+                        <a:srgbClr val="E2E8F0"/>
+                      </a:solidFill>
+                      <a:prstDash val="solid"/>
+                      <a:round/>
+                      <a:headEnd type="none" w="med" len="med"/>
+                      <a:tailEnd type="none" w="med" len="med"/>
+                    </a:lnL>
+                    <a:lnR w="9525" cap="flat" cmpd="sng" algn="ctr">
+                      <a:solidFill>
+                        <a:srgbClr val="E2E8F0"/>
+                      </a:solidFill>
+                      <a:prstDash val="solid"/>
+                      <a:round/>
+                      <a:headEnd type="none" w="med" len="med"/>
+                      <a:tailEnd type="none" w="med" len="med"/>
+                    </a:lnR>
+                    <a:lnT w="9525" cap="flat" cmpd="sng" algn="ctr">
+                      <a:solidFill>
+                        <a:srgbClr val="E2E8F0"/>
+                      </a:solidFill>
+                      <a:prstDash val="solid"/>
+                      <a:round/>
+                      <a:headEnd type="none" w="med" len="med"/>
+                      <a:tailEnd type="none" w="med" len="med"/>
+                    </a:lnT>
+                    <a:lnB w="9525" cap="flat" cmpd="sng" algn="ctr">
+                      <a:solidFill>
+                        <a:srgbClr val="E2E8F0"/>
+                      </a:solidFill>
+                      <a:prstDash val="solid"/>
+                      <a:round/>
+                      <a:headEnd type="none" w="med" len="med"/>
+                      <a:tailEnd type="none" w="med" len="med"/>
+                    </a:lnB>
+                    <a:solidFill>
+                      <a:srgbClr val="FFFFFF"/>
+                    </a:solidFill>
+                  </a:tcPr>
+                </a:tc>
+                <a:tc>
+                  <a:txBody>
+                    <a:bodyPr/>
+                    <a:lstStyle/>
+                    <a:p>
+                      <a:pPr algn="ctr" indent="0" marL="0">
+                        <a:buNone/>
+                      </a:pPr>
+                      <a:r>
+                        <a:rPr lang="en-US" sz="1150" dirty="0">
+                          <a:solidFill>
+                            <a:srgbClr val="1F3B57"/>
+                          </a:solidFill>
+                          <a:latin typeface="Arial" pitchFamily="34" charset="0"/>
+                          <a:ea typeface="Arial" pitchFamily="34" charset="-122"/>
+                          <a:cs typeface="Arial" pitchFamily="34" charset="-120"/>
+                        </a:rPr>
+                        <a:t>1</a:t>
+                      </a:r>
+                      <a:endParaRPr lang="en-US" sz="1150" dirty="0">
+                        <a:latin typeface="Arial" charset="0"/>
+                        <a:ea typeface="Arial" charset="0"/>
+                        <a:cs typeface="Arial" charset="0"/>
+                      </a:endParaRPr>
+                    </a:p>
+                  </a:txBody>
+                  <a:tcPr marL="91440" marR="91440" marT="45720" marB="45720" anchor="ctr">
+                    <a:lnL w="9525" cap="flat" cmpd="sng" algn="ctr">
+                      <a:solidFill>
+                        <a:srgbClr val="E2E8F0"/>
+                      </a:solidFill>
+                      <a:prstDash val="solid"/>
+                      <a:round/>
+                      <a:headEnd type="none" w="med" len="med"/>
+                      <a:tailEnd type="none" w="med" len="med"/>
+                    </a:lnL>
+                    <a:lnR w="9525" cap="flat" cmpd="sng" algn="ctr">
+                      <a:solidFill>
+                        <a:srgbClr val="E2E8F0"/>
+                      </a:solidFill>
+                      <a:prstDash val="solid"/>
+                      <a:round/>
+                      <a:headEnd type="none" w="med" len="med"/>
+                      <a:tailEnd type="none" w="med" len="med"/>
+                    </a:lnR>
+                    <a:lnT w="9525" cap="flat" cmpd="sng" algn="ctr">
+                      <a:solidFill>
+                        <a:srgbClr val="E2E8F0"/>
+                      </a:solidFill>
+                      <a:prstDash val="solid"/>
+                      <a:round/>
+                      <a:headEnd type="none" w="med" len="med"/>
+                      <a:tailEnd type="none" w="med" len="med"/>
+                    </a:lnT>
+                    <a:lnB w="9525" cap="flat" cmpd="sng" algn="ctr">
+                      <a:solidFill>
+                        <a:srgbClr val="E2E8F0"/>
+                      </a:solidFill>
+                      <a:prstDash val="solid"/>
+                      <a:round/>
+                      <a:headEnd type="none" w="med" len="med"/>
+                      <a:tailEnd type="none" w="med" len="med"/>
+                    </a:lnB>
+                    <a:solidFill>
+                      <a:srgbClr val="FFFFFF"/>
+                    </a:solidFill>
+                  </a:tcPr>
+                </a:tc>
+                <a:tc>
+                  <a:txBody>
+                    <a:bodyPr/>
+                    <a:lstStyle/>
+                    <a:p>
+                      <a:pPr algn="ctr" indent="0" marL="0">
+                        <a:buNone/>
+                      </a:pPr>
+                      <a:r>
+                        <a:rPr lang="en-US" sz="1150" b="1" dirty="0">
+                          <a:solidFill>
+                            <a:srgbClr val="1F77B4"/>
+                          </a:solidFill>
+                          <a:latin typeface="Arial" pitchFamily="34" charset="0"/>
+                          <a:ea typeface="Arial" pitchFamily="34" charset="-122"/>
+                          <a:cs typeface="Arial" pitchFamily="34" charset="-120"/>
+                        </a:rPr>
+                        <a:t>0.953</a:t>
+                      </a:r>
+                      <a:endParaRPr lang="en-US" sz="1150" dirty="0">
+                        <a:latin typeface="Arial" charset="0"/>
+                        <a:ea typeface="Arial" charset="0"/>
+                        <a:cs typeface="Arial" charset="0"/>
+                      </a:endParaRPr>
+                    </a:p>
+                  </a:txBody>
+                  <a:tcPr marL="91440" marR="91440" marT="45720" marB="45720" anchor="ctr">
+                    <a:lnL w="9525" cap="flat" cmpd="sng" algn="ctr">
+                      <a:solidFill>
+                        <a:srgbClr val="E2E8F0"/>
+                      </a:solidFill>
+                      <a:prstDash val="solid"/>
+                      <a:round/>
+                      <a:headEnd type="none" w="med" len="med"/>
+                      <a:tailEnd type="none" w="med" len="med"/>
+                    </a:lnL>
+                    <a:lnR w="9525" cap="flat" cmpd="sng" algn="ctr">
+                      <a:solidFill>
+                        <a:srgbClr val="E2E8F0"/>
+                      </a:solidFill>
+                      <a:prstDash val="solid"/>
+                      <a:round/>
+                      <a:headEnd type="none" w="med" len="med"/>
+                      <a:tailEnd type="none" w="med" len="med"/>
+                    </a:lnR>
+                    <a:lnT w="9525" cap="flat" cmpd="sng" algn="ctr">
+                      <a:solidFill>
+                        <a:srgbClr val="E2E8F0"/>
+                      </a:solidFill>
+                      <a:prstDash val="solid"/>
+                      <a:round/>
+                      <a:headEnd type="none" w="med" len="med"/>
+                      <a:tailEnd type="none" w="med" len="med"/>
+                    </a:lnT>
+                    <a:lnB w="9525" cap="flat" cmpd="sng" algn="ctr">
+                      <a:solidFill>
+                        <a:srgbClr val="E2E8F0"/>
+                      </a:solidFill>
+                      <a:prstDash val="solid"/>
+                      <a:round/>
+                      <a:headEnd type="none" w="med" len="med"/>
+                      <a:tailEnd type="none" w="med" len="med"/>
+                    </a:lnB>
+                    <a:solidFill>
+                      <a:srgbClr val="FFFFFF"/>
+                    </a:solidFill>
+                  </a:tcPr>
+                </a:tc>
+                <a:tc>
+                  <a:txBody>
+                    <a:bodyPr/>
+                    <a:lstStyle/>
+                    <a:p>
+                      <a:pPr algn="ctr" indent="0" marL="0">
+                        <a:buNone/>
+                      </a:pPr>
+                      <a:r>
+                        <a:rPr lang="en-US" sz="1150" dirty="0">
+                          <a:solidFill>
+                            <a:srgbClr val="D62728"/>
+                          </a:solidFill>
+                          <a:latin typeface="Arial" pitchFamily="34" charset="0"/>
+                          <a:ea typeface="Arial" pitchFamily="34" charset="-122"/>
+                          <a:cs typeface="Arial" pitchFamily="34" charset="-120"/>
+                        </a:rPr>
+                        <a:t>0.966</a:t>
+                      </a:r>
+                      <a:endParaRPr lang="en-US" sz="1150" dirty="0">
+                        <a:latin typeface="Arial" charset="0"/>
+                        <a:ea typeface="Arial" charset="0"/>
+                        <a:cs typeface="Arial" charset="0"/>
+                      </a:endParaRPr>
+                    </a:p>
+                  </a:txBody>
+                  <a:tcPr marL="91440" marR="91440" marT="45720" marB="45720" anchor="ctr">
+                    <a:lnL w="9525" cap="flat" cmpd="sng" algn="ctr">
+                      <a:solidFill>
+                        <a:srgbClr val="E2E8F0"/>
+                      </a:solidFill>
+                      <a:prstDash val="solid"/>
+                      <a:round/>
+                      <a:headEnd type="none" w="med" len="med"/>
+                      <a:tailEnd type="none" w="med" len="med"/>
+                    </a:lnL>
+                    <a:lnR w="9525" cap="flat" cmpd="sng" algn="ctr">
+                      <a:solidFill>
+                        <a:srgbClr val="E2E8F0"/>
+                      </a:solidFill>
+                      <a:prstDash val="solid"/>
+                      <a:round/>
+                      <a:headEnd type="none" w="med" len="med"/>
+                      <a:tailEnd type="none" w="med" len="med"/>
+                    </a:lnR>
+                    <a:lnT w="9525" cap="flat" cmpd="sng" algn="ctr">
+                      <a:solidFill>
+                        <a:srgbClr val="E2E8F0"/>
+                      </a:solidFill>
+                      <a:prstDash val="solid"/>
+                      <a:round/>
+                      <a:headEnd type="none" w="med" len="med"/>
+                      <a:tailEnd type="none" w="med" len="med"/>
+                    </a:lnT>
+                    <a:lnB w="9525" cap="flat" cmpd="sng" algn="ctr">
+                      <a:solidFill>
+                        <a:srgbClr val="E2E8F0"/>
+                      </a:solidFill>
+                      <a:prstDash val="solid"/>
+                      <a:round/>
+                      <a:headEnd type="none" w="med" len="med"/>
+                      <a:tailEnd type="none" w="med" len="med"/>
+                    </a:lnB>
+                    <a:solidFill>
+                      <a:srgbClr val="FFFFFF"/>
+                    </a:solidFill>
+                  </a:tcPr>
+                </a:tc>
+                <a:tc>
+                  <a:txBody>
+                    <a:bodyPr/>
+                    <a:lstStyle/>
+                    <a:p>
+                      <a:pPr algn="ctr" indent="0" marL="0">
+                        <a:buNone/>
+                      </a:pPr>
+                      <a:r>
+                        <a:rPr lang="en-US" sz="1150" dirty="0">
+                          <a:solidFill>
+                            <a:srgbClr val="1F3B57"/>
+                          </a:solidFill>
+                          <a:latin typeface="Arial" pitchFamily="34" charset="0"/>
+                          <a:ea typeface="Arial" pitchFamily="34" charset="-122"/>
+                          <a:cs typeface="Arial" pitchFamily="34" charset="-120"/>
+                        </a:rPr>
+                        <a:t>0.8690</a:t>
+                      </a:r>
+                      <a:endParaRPr lang="en-US" sz="1150" dirty="0">
+                        <a:latin typeface="Arial" charset="0"/>
+                        <a:ea typeface="Arial" charset="0"/>
+                        <a:cs typeface="Arial" charset="0"/>
+                      </a:endParaRPr>
+                    </a:p>
+                  </a:txBody>
+                  <a:tcPr marL="91440" marR="91440" marT="45720" marB="45720" anchor="ctr">
+                    <a:lnL w="9525" cap="flat" cmpd="sng" algn="ctr">
+                      <a:solidFill>
+                        <a:srgbClr val="E2E8F0"/>
+                      </a:solidFill>
+                      <a:prstDash val="solid"/>
+                      <a:round/>
+                      <a:headEnd type="none" w="med" len="med"/>
+                      <a:tailEnd type="none" w="med" len="med"/>
+                    </a:lnL>
+                    <a:lnR w="9525" cap="flat" cmpd="sng" algn="ctr">
+                      <a:solidFill>
+                        <a:srgbClr val="E2E8F0"/>
+                      </a:solidFill>
+                      <a:prstDash val="solid"/>
+                      <a:round/>
+                      <a:headEnd type="none" w="med" len="med"/>
+                      <a:tailEnd type="none" w="med" len="med"/>
+                    </a:lnR>
+                    <a:lnT w="9525" cap="flat" cmpd="sng" algn="ctr">
+                      <a:solidFill>
+                        <a:srgbClr val="E2E8F0"/>
+                      </a:solidFill>
+                      <a:prstDash val="solid"/>
+                      <a:round/>
+                      <a:headEnd type="none" w="med" len="med"/>
+                      <a:tailEnd type="none" w="med" len="med"/>
+                    </a:lnT>
+                    <a:lnB w="9525" cap="flat" cmpd="sng" algn="ctr">
+                      <a:solidFill>
+                        <a:srgbClr val="E2E8F0"/>
+                      </a:solidFill>
+                      <a:prstDash val="solid"/>
+                      <a:round/>
+                      <a:headEnd type="none" w="med" len="med"/>
+                      <a:tailEnd type="none" w="med" len="med"/>
+                    </a:lnB>
+                    <a:solidFill>
+                      <a:srgbClr val="FFFFFF"/>
+                    </a:solidFill>
+                  </a:tcPr>
+                </a:tc>
+                <a:tc>
+                  <a:txBody>
+                    <a:bodyPr/>
+                    <a:lstStyle/>
+                    <a:p>
+                      <a:pPr algn="ctr" indent="0" marL="0">
+                        <a:buNone/>
+                      </a:pPr>
+                      <a:r>
+                        <a:rPr lang="en-US" sz="1150" dirty="0">
+                          <a:solidFill>
+                            <a:srgbClr val="1F3B57"/>
+                          </a:solidFill>
+                          <a:latin typeface="Arial" pitchFamily="34" charset="0"/>
+                          <a:ea typeface="Arial" pitchFamily="34" charset="-122"/>
+                          <a:cs typeface="Arial" pitchFamily="34" charset="-120"/>
+                        </a:rPr>
+                        <a:t>0.8884  (+1.9%p)</a:t>
+                      </a:r>
+                      <a:endParaRPr lang="en-US" sz="1150" dirty="0">
+                        <a:latin typeface="Arial" charset="0"/>
+                        <a:ea typeface="Arial" charset="0"/>
+                        <a:cs typeface="Arial" charset="0"/>
+                      </a:endParaRPr>
+                    </a:p>
+                  </a:txBody>
+                  <a:tcPr marL="91440" marR="91440" marT="45720" marB="45720" anchor="ctr">
+                    <a:lnL w="9525" cap="flat" cmpd="sng" algn="ctr">
+                      <a:solidFill>
+                        <a:srgbClr val="E2E8F0"/>
+                      </a:solidFill>
+                      <a:prstDash val="solid"/>
+                      <a:round/>
+                      <a:headEnd type="none" w="med" len="med"/>
+                      <a:tailEnd type="none" w="med" len="med"/>
+                    </a:lnL>
+                    <a:lnR w="9525" cap="flat" cmpd="sng" algn="ctr">
+                      <a:solidFill>
+                        <a:srgbClr val="E2E8F0"/>
+                      </a:solidFill>
+                      <a:prstDash val="solid"/>
+                      <a:round/>
+                      <a:headEnd type="none" w="med" len="med"/>
+                      <a:tailEnd type="none" w="med" len="med"/>
+                    </a:lnR>
+                    <a:lnT w="9525" cap="flat" cmpd="sng" algn="ctr">
+                      <a:solidFill>
+                        <a:srgbClr val="E2E8F0"/>
+                      </a:solidFill>
+                      <a:prstDash val="solid"/>
+                      <a:round/>
+                      <a:headEnd type="none" w="med" len="med"/>
+                      <a:tailEnd type="none" w="med" len="med"/>
+                    </a:lnT>
+                    <a:lnB w="9525" cap="flat" cmpd="sng" algn="ctr">
+                      <a:solidFill>
+                        <a:srgbClr val="E2E8F0"/>
+                      </a:solidFill>
+                      <a:prstDash val="solid"/>
+                      <a:round/>
+                      <a:headEnd type="none" w="med" len="med"/>
+                      <a:tailEnd type="none" w="med" len="med"/>
+                    </a:lnB>
+                    <a:solidFill>
+                      <a:srgbClr val="FFFFFF"/>
+                    </a:solidFill>
+                  </a:tcPr>
+                </a:tc>
+              </a:tr>
+              <a:tr h="365760">
+                <a:tc>
+                  <a:txBody>
+                    <a:bodyPr/>
+                    <a:lstStyle/>
+                    <a:p>
+                      <a:pPr algn="ctr" indent="0" marL="0">
+                        <a:buNone/>
+                      </a:pPr>
+                      <a:endParaRPr lang="en-US" sz="1150" dirty="0">
+                        <a:latin typeface="Arial" charset="0"/>
+                        <a:ea typeface="Arial" charset="0"/>
+                        <a:cs typeface="Arial" charset="0"/>
+                      </a:endParaRPr>
+                    </a:p>
+                  </a:txBody>
+                  <a:tcPr marL="91440" marR="91440" marT="45720" marB="45720" anchor="ctr">
+                    <a:lnL w="9525" cap="flat" cmpd="sng" algn="ctr">
+                      <a:solidFill>
+                        <a:srgbClr val="E2E8F0"/>
+                      </a:solidFill>
+                      <a:prstDash val="solid"/>
+                      <a:round/>
+                      <a:headEnd type="none" w="med" len="med"/>
+                      <a:tailEnd type="none" w="med" len="med"/>
+                    </a:lnL>
+                    <a:lnR w="9525" cap="flat" cmpd="sng" algn="ctr">
+                      <a:solidFill>
+                        <a:srgbClr val="E2E8F0"/>
+                      </a:solidFill>
+                      <a:prstDash val="solid"/>
+                      <a:round/>
+                      <a:headEnd type="none" w="med" len="med"/>
+                      <a:tailEnd type="none" w="med" len="med"/>
+                    </a:lnR>
+                    <a:lnT w="9525" cap="flat" cmpd="sng" algn="ctr">
+                      <a:solidFill>
+                        <a:srgbClr val="E2E8F0"/>
+                      </a:solidFill>
+                      <a:prstDash val="solid"/>
+                      <a:round/>
+                      <a:headEnd type="none" w="med" len="med"/>
+                      <a:tailEnd type="none" w="med" len="med"/>
+                    </a:lnT>
+                    <a:lnB w="9525" cap="flat" cmpd="sng" algn="ctr">
+                      <a:solidFill>
+                        <a:srgbClr val="E2E8F0"/>
+                      </a:solidFill>
+                      <a:prstDash val="solid"/>
+                      <a:round/>
+                      <a:headEnd type="none" w="med" len="med"/>
+                      <a:tailEnd type="none" w="med" len="med"/>
+                    </a:lnB>
+                    <a:solidFill>
+                      <a:srgbClr val="FFFFFF"/>
+                    </a:solidFill>
+                  </a:tcPr>
+                </a:tc>
+                <a:tc>
+                  <a:txBody>
+                    <a:bodyPr/>
+                    <a:lstStyle/>
+                    <a:p>
+                      <a:pPr algn="ctr" indent="0" marL="0">
+                        <a:buNone/>
+                      </a:pPr>
+                      <a:r>
+                        <a:rPr lang="en-US" sz="1150" dirty="0">
+                          <a:solidFill>
+                            <a:srgbClr val="1F3B57"/>
+                          </a:solidFill>
+                          <a:latin typeface="Arial" pitchFamily="34" charset="0"/>
+                          <a:ea typeface="Arial" pitchFamily="34" charset="-122"/>
+                          <a:cs typeface="Arial" pitchFamily="34" charset="-120"/>
+                        </a:rPr>
+                        <a:t>3</a:t>
+                      </a:r>
+                      <a:endParaRPr lang="en-US" sz="1150" dirty="0">
+                        <a:latin typeface="Arial" charset="0"/>
+                        <a:ea typeface="Arial" charset="0"/>
+                        <a:cs typeface="Arial" charset="0"/>
+                      </a:endParaRPr>
+                    </a:p>
+                  </a:txBody>
+                  <a:tcPr marL="91440" marR="91440" marT="45720" marB="45720" anchor="ctr">
+                    <a:lnL w="9525" cap="flat" cmpd="sng" algn="ctr">
+                      <a:solidFill>
+                        <a:srgbClr val="E2E8F0"/>
+                      </a:solidFill>
+                      <a:prstDash val="solid"/>
+                      <a:round/>
+                      <a:headEnd type="none" w="med" len="med"/>
+                      <a:tailEnd type="none" w="med" len="med"/>
+                    </a:lnL>
+                    <a:lnR w="9525" cap="flat" cmpd="sng" algn="ctr">
+                      <a:solidFill>
+                        <a:srgbClr val="E2E8F0"/>
+                      </a:solidFill>
+                      <a:prstDash val="solid"/>
+                      <a:round/>
+                      <a:headEnd type="none" w="med" len="med"/>
+                      <a:tailEnd type="none" w="med" len="med"/>
+                    </a:lnR>
+                    <a:lnT w="9525" cap="flat" cmpd="sng" algn="ctr">
+                      <a:solidFill>
+                        <a:srgbClr val="E2E8F0"/>
+                      </a:solidFill>
+                      <a:prstDash val="solid"/>
+                      <a:round/>
+                      <a:headEnd type="none" w="med" len="med"/>
+                      <a:tailEnd type="none" w="med" len="med"/>
+                    </a:lnT>
+                    <a:lnB w="9525" cap="flat" cmpd="sng" algn="ctr">
+                      <a:solidFill>
+                        <a:srgbClr val="E2E8F0"/>
+                      </a:solidFill>
+                      <a:prstDash val="solid"/>
+                      <a:round/>
+                      <a:headEnd type="none" w="med" len="med"/>
+                      <a:tailEnd type="none" w="med" len="med"/>
+                    </a:lnB>
+                    <a:solidFill>
+                      <a:srgbClr val="FFFFFF"/>
+                    </a:solidFill>
+                  </a:tcPr>
+                </a:tc>
+                <a:tc>
+                  <a:txBody>
+                    <a:bodyPr/>
+                    <a:lstStyle/>
+                    <a:p>
+                      <a:pPr algn="ctr" indent="0" marL="0">
+                        <a:buNone/>
+                      </a:pPr>
+                      <a:r>
+                        <a:rPr lang="en-US" sz="1150" b="1" dirty="0">
+                          <a:solidFill>
+                            <a:srgbClr val="1F77B4"/>
+                          </a:solidFill>
+                          <a:latin typeface="Arial" pitchFamily="34" charset="0"/>
+                          <a:ea typeface="Arial" pitchFamily="34" charset="-122"/>
+                          <a:cs typeface="Arial" pitchFamily="34" charset="-120"/>
+                        </a:rPr>
+                        <a:t>0.937</a:t>
+                      </a:r>
+                      <a:endParaRPr lang="en-US" sz="1150" dirty="0">
+                        <a:latin typeface="Arial" charset="0"/>
+                        <a:ea typeface="Arial" charset="0"/>
+                        <a:cs typeface="Arial" charset="0"/>
+                      </a:endParaRPr>
+                    </a:p>
+                  </a:txBody>
+                  <a:tcPr marL="91440" marR="91440" marT="45720" marB="45720" anchor="ctr">
+                    <a:lnL w="9525" cap="flat" cmpd="sng" algn="ctr">
+                      <a:solidFill>
+                        <a:srgbClr val="E2E8F0"/>
+                      </a:solidFill>
+                      <a:prstDash val="solid"/>
+                      <a:round/>
+                      <a:headEnd type="none" w="med" len="med"/>
+                      <a:tailEnd type="none" w="med" len="med"/>
+                    </a:lnL>
+                    <a:lnR w="9525" cap="flat" cmpd="sng" algn="ctr">
+                      <a:solidFill>
+                        <a:srgbClr val="E2E8F0"/>
+                      </a:solidFill>
+                      <a:prstDash val="solid"/>
+                      <a:round/>
+                      <a:headEnd type="none" w="med" len="med"/>
+                      <a:tailEnd type="none" w="med" len="med"/>
+                    </a:lnR>
+                    <a:lnT w="9525" cap="flat" cmpd="sng" algn="ctr">
+                      <a:solidFill>
+                        <a:srgbClr val="E2E8F0"/>
+                      </a:solidFill>
+                      <a:prstDash val="solid"/>
+                      <a:round/>
+                      <a:headEnd type="none" w="med" len="med"/>
+                      <a:tailEnd type="none" w="med" len="med"/>
+                    </a:lnT>
+                    <a:lnB w="9525" cap="flat" cmpd="sng" algn="ctr">
+                      <a:solidFill>
+                        <a:srgbClr val="E2E8F0"/>
+                      </a:solidFill>
+                      <a:prstDash val="solid"/>
+                      <a:round/>
+                      <a:headEnd type="none" w="med" len="med"/>
+                      <a:tailEnd type="none" w="med" len="med"/>
+                    </a:lnB>
+                    <a:solidFill>
+                      <a:srgbClr val="FFFFFF"/>
+                    </a:solidFill>
+                  </a:tcPr>
+                </a:tc>
+                <a:tc>
+                  <a:txBody>
+                    <a:bodyPr/>
+                    <a:lstStyle/>
+                    <a:p>
+                      <a:pPr algn="ctr" indent="0" marL="0">
+                        <a:buNone/>
+                      </a:pPr>
+                      <a:r>
+                        <a:rPr lang="en-US" sz="1150" dirty="0">
+                          <a:solidFill>
+                            <a:srgbClr val="D62728"/>
+                          </a:solidFill>
+                          <a:latin typeface="Arial" pitchFamily="34" charset="0"/>
+                          <a:ea typeface="Arial" pitchFamily="34" charset="-122"/>
+                          <a:cs typeface="Arial" pitchFamily="34" charset="-120"/>
+                        </a:rPr>
+                        <a:t>0.975</a:t>
+                      </a:r>
+                      <a:endParaRPr lang="en-US" sz="1150" dirty="0">
+                        <a:latin typeface="Arial" charset="0"/>
+                        <a:ea typeface="Arial" charset="0"/>
+                        <a:cs typeface="Arial" charset="0"/>
+                      </a:endParaRPr>
+                    </a:p>
+                  </a:txBody>
+                  <a:tcPr marL="91440" marR="91440" marT="45720" marB="45720" anchor="ctr">
+                    <a:lnL w="9525" cap="flat" cmpd="sng" algn="ctr">
+                      <a:solidFill>
+                        <a:srgbClr val="E2E8F0"/>
+                      </a:solidFill>
+                      <a:prstDash val="solid"/>
+                      <a:round/>
+                      <a:headEnd type="none" w="med" len="med"/>
+                      <a:tailEnd type="none" w="med" len="med"/>
+                    </a:lnL>
+                    <a:lnR w="9525" cap="flat" cmpd="sng" algn="ctr">
+                      <a:solidFill>
+                        <a:srgbClr val="E2E8F0"/>
+                      </a:solidFill>
+                      <a:prstDash val="solid"/>
+                      <a:round/>
+                      <a:headEnd type="none" w="med" len="med"/>
+                      <a:tailEnd type="none" w="med" len="med"/>
+                    </a:lnR>
+                    <a:lnT w="9525" cap="flat" cmpd="sng" algn="ctr">
+                      <a:solidFill>
+                        <a:srgbClr val="E2E8F0"/>
+                      </a:solidFill>
+                      <a:prstDash val="solid"/>
+                      <a:round/>
+                      <a:headEnd type="none" w="med" len="med"/>
+                      <a:tailEnd type="none" w="med" len="med"/>
+                    </a:lnT>
+                    <a:lnB w="9525" cap="flat" cmpd="sng" algn="ctr">
+                      <a:solidFill>
+                        <a:srgbClr val="E2E8F0"/>
+                      </a:solidFill>
+                      <a:prstDash val="solid"/>
+                      <a:round/>
+                      <a:headEnd type="none" w="med" len="med"/>
+                      <a:tailEnd type="none" w="med" len="med"/>
+                    </a:lnB>
+                    <a:solidFill>
+                      <a:srgbClr val="FFFFFF"/>
+                    </a:solidFill>
+                  </a:tcPr>
+                </a:tc>
+                <a:tc>
+                  <a:txBody>
+                    <a:bodyPr/>
+                    <a:lstStyle/>
+                    <a:p>
+                      <a:pPr algn="ctr" indent="0" marL="0">
+                        <a:buNone/>
+                      </a:pPr>
+                      <a:r>
+                        <a:rPr lang="en-US" sz="1150" dirty="0">
+                          <a:solidFill>
+                            <a:srgbClr val="1F3B57"/>
+                          </a:solidFill>
+                          <a:latin typeface="Arial" pitchFamily="34" charset="0"/>
+                          <a:ea typeface="Arial" pitchFamily="34" charset="-122"/>
+                          <a:cs typeface="Arial" pitchFamily="34" charset="-120"/>
+                        </a:rPr>
+                        <a:t>0.8740</a:t>
+                      </a:r>
+                      <a:endParaRPr lang="en-US" sz="1150" dirty="0">
+                        <a:latin typeface="Arial" charset="0"/>
+                        <a:ea typeface="Arial" charset="0"/>
+                        <a:cs typeface="Arial" charset="0"/>
+                      </a:endParaRPr>
+                    </a:p>
+                  </a:txBody>
+                  <a:tcPr marL="91440" marR="91440" marT="45720" marB="45720" anchor="ctr">
+                    <a:lnL w="9525" cap="flat" cmpd="sng" algn="ctr">
+                      <a:solidFill>
+                        <a:srgbClr val="E2E8F0"/>
+                      </a:solidFill>
+                      <a:prstDash val="solid"/>
+                      <a:round/>
+                      <a:headEnd type="none" w="med" len="med"/>
+                      <a:tailEnd type="none" w="med" len="med"/>
+                    </a:lnL>
+                    <a:lnR w="9525" cap="flat" cmpd="sng" algn="ctr">
+                      <a:solidFill>
+                        <a:srgbClr val="E2E8F0"/>
+                      </a:solidFill>
+                      <a:prstDash val="solid"/>
+                      <a:round/>
+                      <a:headEnd type="none" w="med" len="med"/>
+                      <a:tailEnd type="none" w="med" len="med"/>
+                    </a:lnR>
+                    <a:lnT w="9525" cap="flat" cmpd="sng" algn="ctr">
+                      <a:solidFill>
+                        <a:srgbClr val="E2E8F0"/>
+                      </a:solidFill>
+                      <a:prstDash val="solid"/>
+                      <a:round/>
+                      <a:headEnd type="none" w="med" len="med"/>
+                      <a:tailEnd type="none" w="med" len="med"/>
+                    </a:lnT>
+                    <a:lnB w="9525" cap="flat" cmpd="sng" algn="ctr">
+                      <a:solidFill>
+                        <a:srgbClr val="E2E8F0"/>
+                      </a:solidFill>
+                      <a:prstDash val="solid"/>
+                      <a:round/>
+                      <a:headEnd type="none" w="med" len="med"/>
+                      <a:tailEnd type="none" w="med" len="med"/>
+                    </a:lnB>
+                    <a:solidFill>
+                      <a:srgbClr val="FFFFFF"/>
+                    </a:solidFill>
+                  </a:tcPr>
+                </a:tc>
+                <a:tc>
+                  <a:txBody>
+                    <a:bodyPr/>
+                    <a:lstStyle/>
+                    <a:p>
+                      <a:pPr algn="ctr" indent="0" marL="0">
+                        <a:buNone/>
+                      </a:pPr>
+                      <a:r>
+                        <a:rPr lang="en-US" sz="1150" dirty="0">
+                          <a:solidFill>
+                            <a:srgbClr val="1F3B57"/>
+                          </a:solidFill>
+                          <a:latin typeface="Arial" pitchFamily="34" charset="0"/>
+                          <a:ea typeface="Arial" pitchFamily="34" charset="-122"/>
+                          <a:cs typeface="Arial" pitchFamily="34" charset="-120"/>
+                        </a:rPr>
+                        <a:t>0.8928  (+1.9%p)</a:t>
+                      </a:r>
+                      <a:endParaRPr lang="en-US" sz="1150" dirty="0">
+                        <a:latin typeface="Arial" charset="0"/>
+                        <a:ea typeface="Arial" charset="0"/>
+                        <a:cs typeface="Arial" charset="0"/>
+                      </a:endParaRPr>
+                    </a:p>
+                  </a:txBody>
+                  <a:tcPr marL="91440" marR="91440" marT="45720" marB="45720" anchor="ctr">
+                    <a:lnL w="9525" cap="flat" cmpd="sng" algn="ctr">
+                      <a:solidFill>
+                        <a:srgbClr val="E2E8F0"/>
+                      </a:solidFill>
+                      <a:prstDash val="solid"/>
+                      <a:round/>
+                      <a:headEnd type="none" w="med" len="med"/>
+                      <a:tailEnd type="none" w="med" len="med"/>
+                    </a:lnL>
+                    <a:lnR w="9525" cap="flat" cmpd="sng" algn="ctr">
+                      <a:solidFill>
+                        <a:srgbClr val="E2E8F0"/>
+                      </a:solidFill>
+                      <a:prstDash val="solid"/>
+                      <a:round/>
+                      <a:headEnd type="none" w="med" len="med"/>
+                      <a:tailEnd type="none" w="med" len="med"/>
+                    </a:lnR>
+                    <a:lnT w="9525" cap="flat" cmpd="sng" algn="ctr">
+                      <a:solidFill>
+                        <a:srgbClr val="E2E8F0"/>
+                      </a:solidFill>
+                      <a:prstDash val="solid"/>
+                      <a:round/>
+                      <a:headEnd type="none" w="med" len="med"/>
+                      <a:tailEnd type="none" w="med" len="med"/>
+                    </a:lnT>
+                    <a:lnB w="9525" cap="flat" cmpd="sng" algn="ctr">
+                      <a:solidFill>
+                        <a:srgbClr val="E2E8F0"/>
+                      </a:solidFill>
+                      <a:prstDash val="solid"/>
+                      <a:round/>
+                      <a:headEnd type="none" w="med" len="med"/>
+                      <a:tailEnd type="none" w="med" len="med"/>
+                    </a:lnB>
+                    <a:solidFill>
+                      <a:srgbClr val="FFFFFF"/>
+                    </a:solidFill>
+                  </a:tcPr>
+                </a:tc>
+              </a:tr>
             </a:tbl>
           </a:graphicData>
         </a:graphic>
@@ -15924,8 +16700,8 @@
         </p:nvSpPr>
         <p:spPr>
           <a:xfrm>
-            <a:off x="502920" y="4526280"/>
-            <a:ext cx="11201400" cy="731520"/>
+            <a:off x="502920" y="4828032"/>
+            <a:ext cx="11201400" cy="777240"/>
           </a:xfrm>
           <a:prstGeom prst="rect">
             <a:avLst/>
@@ -15938,10 +16714,13 @@
           <a:lstStyle/>
           <a:p>
             <a:pPr indent="0" marL="0">
+              <a:spcAft>
+                <a:spcPts val="400"/>
+              </a:spcAft>
               <a:buNone/>
             </a:pPr>
             <a:r>
-              <a:rPr lang="en-US" sz="1250" b="1" dirty="0">
+              <a:rPr lang="en-US" sz="1200" b="1" dirty="0">
                 <a:solidFill>
                   <a:srgbClr val="1F3B57"/>
                 </a:solidFill>
@@ -15949,13 +16728,16 @@
                 <a:ea typeface="Arial" pitchFamily="34" charset="-122"/>
                 <a:cs typeface="Arial" pitchFamily="34" charset="-120"/>
               </a:rPr>
-              <a:t>두 곡선이 반대로 움직입니다.  </a:t>
+              <a:t>3B에서는 두 곡선이 반대로 움직여 N=2에서 교차합니다.  </a:t>
             </a:r>
             <a:pPr indent="0" marL="0">
+              <a:spcAft>
+                <a:spcPts val="400"/>
+              </a:spcAft>
               <a:buNone/>
             </a:pPr>
             <a:r>
-              <a:rPr lang="en-US" sz="1250" dirty="0">
+              <a:rPr lang="en-US" sz="1200" dirty="0">
                 <a:solidFill>
                   <a:srgbClr val="1F3B57"/>
                 </a:solidFill>
@@ -15963,9 +16745,29 @@
                 <a:ea typeface="Arial" pitchFamily="34" charset="-122"/>
                 <a:cs typeface="Arial" pitchFamily="34" charset="-120"/>
               </a:rPr>
-              <a:t>컨트롤러 정확도는 방해가 늘수록 올라가고(0.693 → 0.730), 손익분기는 내려갑니다(0.761 → 0.569). 손상이 클수록 오판 비용이 상대적으로 싸지고, 동시에 반사실 신호가 강해져 판정도 정확해지기 때문입니다.</a:t>
+              <a:t>컨트롤러는 방해가 늘수록 정확해지고(0.693 → 0.730), 손익분기는 내려갑니다(0.761 → 0.569).</a:t>
             </a:r>
-            <a:endParaRPr lang="en-US" sz="1250" dirty="0"/>
+            <a:endParaRPr lang="en-US" sz="1200" dirty="0"/>
+          </a:p>
+          <a:p>
+            <a:pPr indent="0" marL="0">
+              <a:spcAft>
+                <a:spcPts val="400"/>
+              </a:spcAft>
+              <a:buNone/>
+            </a:pPr>
+            <a:r>
+              <a:rPr lang="en-US" sz="1200" dirty="0">
+                <a:solidFill>
+                  <a:srgbClr val="1F3B57"/>
+                </a:solidFill>
+                <a:latin typeface="Arial" pitchFamily="34" charset="0"/>
+                <a:ea typeface="Arial" pitchFamily="34" charset="-122"/>
+                <a:cs typeface="Arial" pitchFamily="34" charset="-120"/>
+              </a:rPr>
+              <a:t>7B에서는 컨트롤러가 0.95로 훨씬 정확한데도 손익분기가 0.97이라 순이득이 남지 않습니다 — 고칠 손상 자체가 작기 때문입니다. 컨트롤러가 되는 곳에는 고칠 게 없고, 고칠 게 많은 곳에서 컨트롤러가 겨우 됩니다.</a:t>
+            </a:r>
+            <a:endParaRPr lang="en-US" sz="1200" dirty="0"/>
           </a:p>
         </p:txBody>
       </p:sp>
@@ -16002,7 +16804,7 @@
                 <a:ea typeface="Arial" pitchFamily="34" charset="-122"/>
                 <a:cs typeface="Arial" pitchFamily="34" charset="-120"/>
               </a:rPr>
-              <a:t>3B n=300. 컨트롤러 정확도와 손익분기는 정확한 값이며, '실현 성능'은 오판 시 조건을 근사한 낙관값 — 0.730 &gt; 0.569 판정은 근사에 의존하지 않음. forward N+1회 필요(정확도 트랙)</a:t>
+              <a:t>n=300/모델. 컨트롤러 정확도와 손익분기는 정확한 값이며, '실현 성능'은 오판 시 조건을 근사한 낙관값 — 0.730 &gt; 0.569 판정은 근사에 의존하지 않음. forward N+1회 필요(정확도 트랙)</a:t>
             </a:r>
             <a:endParaRPr lang="en-US" sz="1000" dirty="0"/>
           </a:p>
@@ -16063,7 +16865,7 @@
                 <a:ea typeface="Arial" pitchFamily="34" charset="-122"/>
                 <a:cs typeface="Arial" pitchFamily="34" charset="-120"/>
               </a:rPr>
-              <a:t>→ 무관 입력이 많을수록 방법이 더 잘 작동합니다. 방법이 필요한 상황이 곧 방법이 통하는 상황입니다</a:t>
+              <a:t>→ 이 방법의 가치는 소형 모델 + 다수 무관 입력 레짐에 있습니다. 7B 이상은 "되지만 고칠 게 없다"가 정직한 서술입니다</a:t>
             </a:r>
             <a:endParaRPr lang="en-US" sz="1250" dirty="0"/>
           </a:p>

</xml_diff>

<commit_message>
Fold the harder need-all and lambda sweep into slides 5 and 8
Slide 5 now shows all three question types with their evidence quality stated:
the 'any' row is marked unusable because it sits at AUC 0.99, the new 'all' row
carries -0.0250 with a CI containing zero, and 'both' keeps its clear cost. The
selector defence is rewritten to rest on what all-of-3 makes structurally true —
no image can be dropped — rather than on isolation being free.

Slide 8 gains the lambda curve, which rises monotonically to hard blocking with
no interior optimum but recovers 74% of the damage at lambda=4. That continuous
strength axis contrasts with a selector's all-or-nothing call, whose errors
collapse AUC to 0.015-0.043.

Co-Authored-By: Claude Fable 5 <noreply@anthropic.com>
</commit_message>
<xml_diff>
--- a/meeting/SourceDepth_meeting_v5.pptx
+++ b/meeting/SourceDepth_meeting_v5.pptx
@@ -9675,7 +9675,7 @@
           </p:nvPr>
         </p:nvGraphicFramePr>
         <p:xfrm>
-          <a:off x="502920" y="1371600"/>
+          <a:off x="502920" y="1325880"/>
           <a:ext cx="11201400" cy="914400"/>
         </p:xfrm>
         <a:graphic>
@@ -9688,7 +9688,7 @@
                 <a:gridCol w="2800350"/>
                 <a:gridCol w="2800350"/>
               </a:tblGrid>
-              <a:tr h="457200">
+              <a:tr h="402336">
                 <a:tc>
                   <a:txBody>
                     <a:bodyPr/>
@@ -9962,7 +9962,7 @@
                   </a:tcPr>
                 </a:tc>
               </a:tr>
-              <a:tr h="566928">
+              <a:tr h="457200">
                 <a:tc>
                   <a:txBody>
                     <a:bodyPr/>
@@ -10108,7 +10108,7 @@
                         <a:buNone/>
                       </a:pPr>
                       <a:r>
-                        <a:rPr lang="en-US" sz="1150" dirty="0">
+                        <a:rPr lang="en-US" sz="1050" dirty="0">
                           <a:solidFill>
                             <a:srgbClr val="1F3B57"/>
                           </a:solidFill>
@@ -10116,9 +10116,9 @@
                           <a:ea typeface="Arial" pitchFamily="34" charset="-122"/>
                           <a:cs typeface="Arial" pitchFamily="34" charset="-120"/>
                         </a:rPr>
-                        <a:t>3B +0.0009 · 7B −0.0022  (CI가 0 포함)</a:t>
+                        <a:t>+0.0009 — 단 이 태스크는 AUC 0.99로 천장</a:t>
                       </a:r>
-                      <a:endParaRPr lang="en-US" sz="1150" dirty="0">
+                      <a:endParaRPr lang="en-US" sz="1050" dirty="0">
                         <a:latin typeface="Arial" charset="0"/>
                         <a:ea typeface="Arial" charset="0"/>
                         <a:cs typeface="Arial" charset="0"/>
@@ -10178,13 +10178,13 @@
                       <a:r>
                         <a:rPr lang="en-US" sz="1150" b="1" dirty="0">
                           <a:solidFill>
-                            <a:srgbClr val="2E8B57"/>
+                            <a:srgbClr val="6B7280"/>
                           </a:solidFill>
                           <a:latin typeface="Arial" pitchFamily="34" charset="0"/>
                           <a:ea typeface="Arial" pitchFamily="34" charset="-122"/>
                           <a:cs typeface="Arial" pitchFamily="34" charset="-120"/>
                         </a:rPr>
-                        <a:t>불필요</a:t>
+                        <a:t>판정 불가</a:t>
                       </a:r>
                       <a:endParaRPr lang="en-US" sz="1150" dirty="0">
                         <a:latin typeface="Arial" charset="0"/>
@@ -10236,7 +10236,281 @@
                   </a:tcPr>
                 </a:tc>
               </a:tr>
-              <a:tr h="566928">
+              <a:tr h="457200">
+                <a:tc>
+                  <a:txBody>
+                    <a:bodyPr/>
+                    <a:lstStyle/>
+                    <a:p>
+                      <a:pPr algn="ctr" indent="0" marL="0">
+                        <a:buNone/>
+                      </a:pPr>
+                      <a:r>
+                        <a:rPr lang="en-US" sz="1150" b="1" dirty="0">
+                          <a:solidFill>
+                            <a:srgbClr val="1F3B57"/>
+                          </a:solidFill>
+                          <a:latin typeface="Arial" pitchFamily="34" charset="0"/>
+                          <a:ea typeface="Arial" pitchFamily="34" charset="-122"/>
+                          <a:cs typeface="Arial" pitchFamily="34" charset="-120"/>
+                        </a:rPr>
+                        <a:t>존재 확인 (all)</a:t>
+                      </a:r>
+                      <a:endParaRPr lang="en-US" sz="1150" dirty="0">
+                        <a:latin typeface="Arial" charset="0"/>
+                        <a:ea typeface="Arial" charset="0"/>
+                        <a:cs typeface="Arial" charset="0"/>
+                      </a:endParaRPr>
+                    </a:p>
+                  </a:txBody>
+                  <a:tcPr marL="91440" marR="91440" marT="45720" marB="45720" anchor="ctr">
+                    <a:lnL w="9525" cap="flat" cmpd="sng" algn="ctr">
+                      <a:solidFill>
+                        <a:srgbClr val="E2E8F0"/>
+                      </a:solidFill>
+                      <a:prstDash val="solid"/>
+                      <a:round/>
+                      <a:headEnd type="none" w="med" len="med"/>
+                      <a:tailEnd type="none" w="med" len="med"/>
+                    </a:lnL>
+                    <a:lnR w="9525" cap="flat" cmpd="sng" algn="ctr">
+                      <a:solidFill>
+                        <a:srgbClr val="E2E8F0"/>
+                      </a:solidFill>
+                      <a:prstDash val="solid"/>
+                      <a:round/>
+                      <a:headEnd type="none" w="med" len="med"/>
+                      <a:tailEnd type="none" w="med" len="med"/>
+                    </a:lnR>
+                    <a:lnT w="9525" cap="flat" cmpd="sng" algn="ctr">
+                      <a:solidFill>
+                        <a:srgbClr val="E2E8F0"/>
+                      </a:solidFill>
+                      <a:prstDash val="solid"/>
+                      <a:round/>
+                      <a:headEnd type="none" w="med" len="med"/>
+                      <a:tailEnd type="none" w="med" len="med"/>
+                    </a:lnT>
+                    <a:lnB w="9525" cap="flat" cmpd="sng" algn="ctr">
+                      <a:solidFill>
+                        <a:srgbClr val="E2E8F0"/>
+                      </a:solidFill>
+                      <a:prstDash val="solid"/>
+                      <a:round/>
+                      <a:headEnd type="none" w="med" len="med"/>
+                      <a:tailEnd type="none" w="med" len="med"/>
+                    </a:lnB>
+                    <a:solidFill>
+                      <a:srgbClr val="FFFFFF"/>
+                    </a:solidFill>
+                  </a:tcPr>
+                </a:tc>
+                <a:tc>
+                  <a:txBody>
+                    <a:bodyPr/>
+                    <a:lstStyle/>
+                    <a:p>
+                      <a:pPr algn="ctr" indent="0" marL="0">
+                        <a:buNone/>
+                      </a:pPr>
+                      <a:r>
+                        <a:rPr lang="en-US" sz="1100" dirty="0">
+                          <a:solidFill>
+                            <a:srgbClr val="1F3B57"/>
+                          </a:solidFill>
+                          <a:latin typeface="Arial" pitchFamily="34" charset="0"/>
+                          <a:ea typeface="Arial" pitchFamily="34" charset="-122"/>
+                          <a:cs typeface="Arial" pitchFamily="34" charset="-120"/>
+                        </a:rPr>
+                        <a:t>"모두 X를 담고 있나?"</a:t>
+                      </a:r>
+                      <a:endParaRPr lang="en-US" sz="1100" dirty="0">
+                        <a:latin typeface="Arial" charset="0"/>
+                        <a:ea typeface="Arial" charset="0"/>
+                        <a:cs typeface="Arial" charset="0"/>
+                      </a:endParaRPr>
+                    </a:p>
+                  </a:txBody>
+                  <a:tcPr marL="91440" marR="91440" marT="45720" marB="45720" anchor="ctr">
+                    <a:lnL w="9525" cap="flat" cmpd="sng" algn="ctr">
+                      <a:solidFill>
+                        <a:srgbClr val="E2E8F0"/>
+                      </a:solidFill>
+                      <a:prstDash val="solid"/>
+                      <a:round/>
+                      <a:headEnd type="none" w="med" len="med"/>
+                      <a:tailEnd type="none" w="med" len="med"/>
+                    </a:lnL>
+                    <a:lnR w="9525" cap="flat" cmpd="sng" algn="ctr">
+                      <a:solidFill>
+                        <a:srgbClr val="E2E8F0"/>
+                      </a:solidFill>
+                      <a:prstDash val="solid"/>
+                      <a:round/>
+                      <a:headEnd type="none" w="med" len="med"/>
+                      <a:tailEnd type="none" w="med" len="med"/>
+                    </a:lnR>
+                    <a:lnT w="9525" cap="flat" cmpd="sng" algn="ctr">
+                      <a:solidFill>
+                        <a:srgbClr val="E2E8F0"/>
+                      </a:solidFill>
+                      <a:prstDash val="solid"/>
+                      <a:round/>
+                      <a:headEnd type="none" w="med" len="med"/>
+                      <a:tailEnd type="none" w="med" len="med"/>
+                    </a:lnT>
+                    <a:lnB w="9525" cap="flat" cmpd="sng" algn="ctr">
+                      <a:solidFill>
+                        <a:srgbClr val="E2E8F0"/>
+                      </a:solidFill>
+                      <a:prstDash val="solid"/>
+                      <a:round/>
+                      <a:headEnd type="none" w="med" len="med"/>
+                      <a:tailEnd type="none" w="med" len="med"/>
+                    </a:lnB>
+                    <a:solidFill>
+                      <a:srgbClr val="FFFFFF"/>
+                    </a:solidFill>
+                  </a:tcPr>
+                </a:tc>
+                <a:tc>
+                  <a:txBody>
+                    <a:bodyPr/>
+                    <a:lstStyle/>
+                    <a:p>
+                      <a:pPr algn="ctr" indent="0" marL="0">
+                        <a:buNone/>
+                      </a:pPr>
+                      <a:r>
+                        <a:rPr lang="en-US" sz="1050" dirty="0">
+                          <a:solidFill>
+                            <a:srgbClr val="1F3B57"/>
+                          </a:solidFill>
+                          <a:latin typeface="Arial" pitchFamily="34" charset="0"/>
+                          <a:ea typeface="Arial" pitchFamily="34" charset="-122"/>
+                          <a:cs typeface="Arial" pitchFamily="34" charset="-120"/>
+                        </a:rPr>
+                        <a:t>−0.0250  CI [−0.057, +0.009] — 0과 구분 안 됨 (AUC 0.65)</a:t>
+                      </a:r>
+                      <a:endParaRPr lang="en-US" sz="1050" dirty="0">
+                        <a:latin typeface="Arial" charset="0"/>
+                        <a:ea typeface="Arial" charset="0"/>
+                        <a:cs typeface="Arial" charset="0"/>
+                      </a:endParaRPr>
+                    </a:p>
+                  </a:txBody>
+                  <a:tcPr marL="91440" marR="91440" marT="45720" marB="45720" anchor="ctr">
+                    <a:lnL w="9525" cap="flat" cmpd="sng" algn="ctr">
+                      <a:solidFill>
+                        <a:srgbClr val="E2E8F0"/>
+                      </a:solidFill>
+                      <a:prstDash val="solid"/>
+                      <a:round/>
+                      <a:headEnd type="none" w="med" len="med"/>
+                      <a:tailEnd type="none" w="med" len="med"/>
+                    </a:lnL>
+                    <a:lnR w="9525" cap="flat" cmpd="sng" algn="ctr">
+                      <a:solidFill>
+                        <a:srgbClr val="E2E8F0"/>
+                      </a:solidFill>
+                      <a:prstDash val="solid"/>
+                      <a:round/>
+                      <a:headEnd type="none" w="med" len="med"/>
+                      <a:tailEnd type="none" w="med" len="med"/>
+                    </a:lnR>
+                    <a:lnT w="9525" cap="flat" cmpd="sng" algn="ctr">
+                      <a:solidFill>
+                        <a:srgbClr val="E2E8F0"/>
+                      </a:solidFill>
+                      <a:prstDash val="solid"/>
+                      <a:round/>
+                      <a:headEnd type="none" w="med" len="med"/>
+                      <a:tailEnd type="none" w="med" len="med"/>
+                    </a:lnT>
+                    <a:lnB w="9525" cap="flat" cmpd="sng" algn="ctr">
+                      <a:solidFill>
+                        <a:srgbClr val="E2E8F0"/>
+                      </a:solidFill>
+                      <a:prstDash val="solid"/>
+                      <a:round/>
+                      <a:headEnd type="none" w="med" len="med"/>
+                      <a:tailEnd type="none" w="med" len="med"/>
+                    </a:lnB>
+                    <a:solidFill>
+                      <a:srgbClr val="FFFFFF"/>
+                    </a:solidFill>
+                  </a:tcPr>
+                </a:tc>
+                <a:tc>
+                  <a:txBody>
+                    <a:bodyPr/>
+                    <a:lstStyle/>
+                    <a:p>
+                      <a:pPr algn="ctr" indent="0" marL="0">
+                        <a:buNone/>
+                      </a:pPr>
+                      <a:r>
+                        <a:rPr lang="en-US" sz="1150" b="1" dirty="0">
+                          <a:solidFill>
+                            <a:srgbClr val="E8890C"/>
+                          </a:solidFill>
+                          <a:latin typeface="Arial" pitchFamily="34" charset="0"/>
+                          <a:ea typeface="Arial" pitchFamily="34" charset="-122"/>
+                          <a:cs typeface="Arial" pitchFamily="34" charset="-120"/>
+                        </a:rPr>
+                        <a:t>작은 비용</a:t>
+                      </a:r>
+                      <a:endParaRPr lang="en-US" sz="1150" dirty="0">
+                        <a:latin typeface="Arial" charset="0"/>
+                        <a:ea typeface="Arial" charset="0"/>
+                        <a:cs typeface="Arial" charset="0"/>
+                      </a:endParaRPr>
+                    </a:p>
+                  </a:txBody>
+                  <a:tcPr marL="91440" marR="91440" marT="45720" marB="45720" anchor="ctr">
+                    <a:lnL w="9525" cap="flat" cmpd="sng" algn="ctr">
+                      <a:solidFill>
+                        <a:srgbClr val="E2E8F0"/>
+                      </a:solidFill>
+                      <a:prstDash val="solid"/>
+                      <a:round/>
+                      <a:headEnd type="none" w="med" len="med"/>
+                      <a:tailEnd type="none" w="med" len="med"/>
+                    </a:lnL>
+                    <a:lnR w="9525" cap="flat" cmpd="sng" algn="ctr">
+                      <a:solidFill>
+                        <a:srgbClr val="E2E8F0"/>
+                      </a:solidFill>
+                      <a:prstDash val="solid"/>
+                      <a:round/>
+                      <a:headEnd type="none" w="med" len="med"/>
+                      <a:tailEnd type="none" w="med" len="med"/>
+                    </a:lnR>
+                    <a:lnT w="9525" cap="flat" cmpd="sng" algn="ctr">
+                      <a:solidFill>
+                        <a:srgbClr val="E2E8F0"/>
+                      </a:solidFill>
+                      <a:prstDash val="solid"/>
+                      <a:round/>
+                      <a:headEnd type="none" w="med" len="med"/>
+                      <a:tailEnd type="none" w="med" len="med"/>
+                    </a:lnT>
+                    <a:lnB w="9525" cap="flat" cmpd="sng" algn="ctr">
+                      <a:solidFill>
+                        <a:srgbClr val="E2E8F0"/>
+                      </a:solidFill>
+                      <a:prstDash val="solid"/>
+                      <a:round/>
+                      <a:headEnd type="none" w="med" len="med"/>
+                      <a:tailEnd type="none" w="med" len="med"/>
+                    </a:lnB>
+                    <a:solidFill>
+                      <a:srgbClr val="FFFFFF"/>
+                    </a:solidFill>
+                  </a:tcPr>
+                </a:tc>
+              </a:tr>
+              <a:tr h="457200">
                 <a:tc>
                   <a:txBody>
                     <a:bodyPr/>
@@ -10382,7 +10656,7 @@
                         <a:buNone/>
                       </a:pPr>
                       <a:r>
-                        <a:rPr lang="en-US" sz="1150" dirty="0">
+                        <a:rPr lang="en-US" sz="1050" dirty="0">
                           <a:solidFill>
                             <a:srgbClr val="1F3B57"/>
                           </a:solidFill>
@@ -10392,7 +10666,7 @@
                         </a:rPr>
                         <a:t>3B R1 −12.0%p · 7B R1 −9.0%p · RB −16.0%p</a:t>
                       </a:r>
-                      <a:endParaRPr lang="en-US" sz="1150" dirty="0">
+                      <a:endParaRPr lang="en-US" sz="1050" dirty="0">
                         <a:latin typeface="Arial" charset="0"/>
                         <a:ea typeface="Arial" charset="0"/>
                         <a:cs typeface="Arial" charset="0"/>
@@ -10522,7 +10796,7 @@
         </p:nvSpPr>
         <p:spPr>
           <a:xfrm>
-            <a:off x="502920" y="3108960"/>
+            <a:off x="502920" y="3145536"/>
             <a:ext cx="11201400" cy="1572768"/>
           </a:xfrm>
           <a:prstGeom prst="roundRect">
@@ -10549,7 +10823,7 @@
         </p:nvSpPr>
         <p:spPr>
           <a:xfrm>
-            <a:off x="777240" y="3255264"/>
+            <a:off x="777240" y="3291840"/>
             <a:ext cx="10698480" cy="292608"/>
           </a:xfrm>
           <a:prstGeom prst="rect">
@@ -10588,7 +10862,7 @@
         </p:nvSpPr>
         <p:spPr>
           <a:xfrm>
-            <a:off x="777240" y="3621024"/>
+            <a:off x="777240" y="3657600"/>
             <a:ext cx="10698480" cy="1005840"/>
           </a:xfrm>
           <a:prstGeom prst="rect">
@@ -10616,7 +10890,7 @@
                 <a:ea typeface="Arial" pitchFamily="34" charset="-122"/>
                 <a:cs typeface="Arial" pitchFamily="34" charset="-120"/>
               </a:rPr>
-              <a:t>앞단 selector는 이미지 단위로 all-or-nothing 결정을 내립니다. 그런데 최적 정책은 질문 유형에 따라 갈립니다 — 존재 확인에서는 무관 이미지의 읽기를 막아야 하고, 비교에서는 이미지 간 attention을 살려둬야 합니다.</a:t>
+              <a:t>앞단 selector는 이미지 단위로 all-or-nothing 결정을 내립니다. 그런데 최적 정책은 질문 유형에 따라 갈립니다 — 존재 확인에서는 무관 이미지의 읽기를 막아야 하고, 비교에서는 이미지 간 attention을 살려둬야 합니다. all-of-3처럼 모든 이미지가 정답에 관여하는 질문에서는 애초에 버릴 대상이 없습니다.</a:t>
             </a:r>
             <a:endParaRPr lang="en-US" sz="1150" dirty="0"/>
           </a:p>
@@ -10675,7 +10949,7 @@
                 <a:ea typeface="Arial" pitchFamily="34" charset="-122"/>
                 <a:cs typeface="Arial" pitchFamily="34" charset="-120"/>
               </a:rPr>
-              <a:t>any 태스크는 AUC 0.99로 천장에 가까워 증거력이 제한적 — 더 어려운 need-all 셋(all-of-3)을 현재 측정 중</a:t>
+              <a:t>all-of-3에서는 어떤 이미지도 버릴 수 없다는 것이 설계상 자명하며, 이는 고립 비용과 무관하게 성립합니다</a:t>
             </a:r>
             <a:endParaRPr lang="en-US" sz="1000" dirty="0"/>
           </a:p>
@@ -16989,7 +17263,7 @@
           </p:nvPr>
         </p:nvGraphicFramePr>
         <p:xfrm>
-          <a:off x="502920" y="1325880"/>
+          <a:off x="502920" y="1298448"/>
           <a:ext cx="11201400" cy="914400"/>
         </p:xfrm>
         <a:graphic>
@@ -17003,7 +17277,7 @@
                 <a:gridCol w="2240280"/>
                 <a:gridCol w="2240280"/>
               </a:tblGrid>
-              <a:tr h="438912">
+              <a:tr h="402336">
                 <a:tc>
                   <a:txBody>
                     <a:bodyPr/>
@@ -17345,7 +17619,7 @@
                   </a:tcPr>
                 </a:tc>
               </a:tr>
-              <a:tr h="384048">
+              <a:tr h="347472">
                 <a:tc>
                   <a:txBody>
                     <a:bodyPr/>
@@ -17687,7 +17961,7 @@
                   </a:tcPr>
                 </a:tc>
               </a:tr>
-              <a:tr h="384048">
+              <a:tr h="347472">
                 <a:tc>
                   <a:txBody>
                     <a:bodyPr/>
@@ -18029,7 +18303,7 @@
                   </a:tcPr>
                 </a:tc>
               </a:tr>
-              <a:tr h="420624">
+              <a:tr h="384048">
                 <a:tc>
                   <a:txBody>
                     <a:bodyPr/>
@@ -18371,7 +18645,7 @@
                   </a:tcPr>
                 </a:tc>
               </a:tr>
-              <a:tr h="420624">
+              <a:tr h="384048">
                 <a:tc>
                   <a:txBody>
                     <a:bodyPr/>
@@ -18713,7 +18987,7 @@
                   </a:tcPr>
                 </a:tc>
               </a:tr>
-              <a:tr h="384048">
+              <a:tr h="347472">
                 <a:tc>
                   <a:txBody>
                     <a:bodyPr/>
@@ -19061,18 +19335,1087 @@
       </p:graphicFrame>
       <p:sp>
         <p:nvSpPr>
-          <p:cNvPr id="5" name="Shape 2"/>
+          <p:cNvPr id="5" name="Text 2"/>
           <p:cNvSpPr/>
           <p:nvPr/>
         </p:nvSpPr>
         <p:spPr>
           <a:xfrm>
-            <a:off x="502920" y="3840480"/>
-            <a:ext cx="11201400" cy="1691640"/>
+            <a:off x="502920" y="3602736"/>
+            <a:ext cx="11201400" cy="256032"/>
+          </a:xfrm>
+          <a:prstGeom prst="rect">
+            <a:avLst/>
+          </a:prstGeom>
+          <a:noFill/>
+          <a:ln/>
+        </p:spPr>
+        <p:txBody>
+          <a:bodyPr wrap="square" lIns="0" tIns="0" rIns="0" bIns="0" rtlCol="0" anchor="ctr"/>
+          <a:lstStyle/>
+          <a:p>
+            <a:pPr indent="0" marL="0">
+              <a:buNone/>
+            </a:pPr>
+            <a:r>
+              <a:rPr lang="en-US" sz="1150" b="1" dirty="0">
+                <a:solidFill>
+                  <a:srgbClr val="1F3B57"/>
+                </a:solidFill>
+                <a:latin typeface="Arial" pitchFamily="34" charset="0"/>
+                <a:ea typeface="Arial" pitchFamily="34" charset="-122"/>
+                <a:cs typeface="Arial" pitchFamily="34" charset="-120"/>
+              </a:rPr>
+              <a:t>개입 강도는 연속입니다 — 앞단 selector에는 없는 축 (방해 1장, 3B, n=300)</a:t>
+            </a:r>
+            <a:endParaRPr lang="en-US" sz="1150" dirty="0"/>
+          </a:p>
+        </p:txBody>
+      </p:sp>
+      <p:graphicFrame>
+        <p:nvGraphicFramePr>
+          <p:cNvPr id="17" name="Table 1"/>
+          <p:cNvGraphicFramePr>
+            <a:graphicFrameLocks noGrp="1"/>
+          </p:cNvGraphicFramePr>
+          <p:nvPr>
+            <p:extLst>
+              <p:ext uri="{D42A27DB-BD31-4B8C-83A1-F6EECF244321}">
+                <p14:modId xmlns:p14="http://schemas.microsoft.com/office/powerpoint/2010/main" val="1579011935"/>
+              </p:ext>
+            </p:extLst>
+          </p:nvPr>
+        </p:nvGraphicFramePr>
+        <p:xfrm>
+          <a:off x="502920" y="3913632"/>
+          <a:ext cx="11201400" cy="914400"/>
+        </p:xfrm>
+        <a:graphic>
+          <a:graphicData uri="http://schemas.openxmlformats.org/drawingml/2006/table">
+            <a:tbl>
+              <a:tblPr/>
+              <a:tblGrid>
+                <a:gridCol w="1600200"/>
+                <a:gridCol w="1600200"/>
+                <a:gridCol w="1600200"/>
+                <a:gridCol w="1600200"/>
+                <a:gridCol w="1600200"/>
+                <a:gridCol w="1600200"/>
+                <a:gridCol w="1600200"/>
+              </a:tblGrid>
+              <a:tr h="365760">
+                <a:tc>
+                  <a:txBody>
+                    <a:bodyPr/>
+                    <a:lstStyle/>
+                    <a:p>
+                      <a:pPr algn="ctr" indent="0" marL="0">
+                        <a:buNone/>
+                      </a:pPr>
+                      <a:r>
+                        <a:rPr lang="en-US" sz="1150" b="1" dirty="0">
+                          <a:solidFill>
+                            <a:srgbClr val="FFFFFF"/>
+                          </a:solidFill>
+                          <a:latin typeface="Arial" pitchFamily="34" charset="0"/>
+                          <a:ea typeface="Arial" pitchFamily="34" charset="-122"/>
+                          <a:cs typeface="Arial" pitchFamily="34" charset="-120"/>
+                        </a:rPr>
+                        <a:t>λ (억제 강도)</a:t>
+                      </a:r>
+                      <a:endParaRPr lang="en-US" sz="1150" dirty="0">
+                        <a:latin typeface="Arial" charset="0"/>
+                        <a:ea typeface="Arial" charset="0"/>
+                        <a:cs typeface="Arial" charset="0"/>
+                      </a:endParaRPr>
+                    </a:p>
+                  </a:txBody>
+                  <a:tcPr marL="91440" marR="91440" marT="45720" marB="45720" anchor="ctr">
+                    <a:lnL w="9525" cap="flat" cmpd="sng" algn="ctr">
+                      <a:solidFill>
+                        <a:srgbClr val="E2E8F0"/>
+                      </a:solidFill>
+                      <a:prstDash val="solid"/>
+                      <a:round/>
+                      <a:headEnd type="none" w="med" len="med"/>
+                      <a:tailEnd type="none" w="med" len="med"/>
+                    </a:lnL>
+                    <a:lnR w="9525" cap="flat" cmpd="sng" algn="ctr">
+                      <a:solidFill>
+                        <a:srgbClr val="E2E8F0"/>
+                      </a:solidFill>
+                      <a:prstDash val="solid"/>
+                      <a:round/>
+                      <a:headEnd type="none" w="med" len="med"/>
+                      <a:tailEnd type="none" w="med" len="med"/>
+                    </a:lnR>
+                    <a:lnT w="9525" cap="flat" cmpd="sng" algn="ctr">
+                      <a:solidFill>
+                        <a:srgbClr val="E2E8F0"/>
+                      </a:solidFill>
+                      <a:prstDash val="solid"/>
+                      <a:round/>
+                      <a:headEnd type="none" w="med" len="med"/>
+                      <a:tailEnd type="none" w="med" len="med"/>
+                    </a:lnT>
+                    <a:lnB w="9525" cap="flat" cmpd="sng" algn="ctr">
+                      <a:solidFill>
+                        <a:srgbClr val="E2E8F0"/>
+                      </a:solidFill>
+                      <a:prstDash val="solid"/>
+                      <a:round/>
+                      <a:headEnd type="none" w="med" len="med"/>
+                      <a:tailEnd type="none" w="med" len="med"/>
+                    </a:lnB>
+                    <a:solidFill>
+                      <a:srgbClr val="1F3B57"/>
+                    </a:solidFill>
+                  </a:tcPr>
+                </a:tc>
+                <a:tc>
+                  <a:txBody>
+                    <a:bodyPr/>
+                    <a:lstStyle/>
+                    <a:p>
+                      <a:pPr algn="ctr" indent="0" marL="0">
+                        <a:buNone/>
+                      </a:pPr>
+                      <a:r>
+                        <a:rPr lang="en-US" sz="1150" b="1" dirty="0">
+                          <a:solidFill>
+                            <a:srgbClr val="FFFFFF"/>
+                          </a:solidFill>
+                          <a:latin typeface="Arial" pitchFamily="34" charset="0"/>
+                          <a:ea typeface="Arial" pitchFamily="34" charset="-122"/>
+                          <a:cs typeface="Arial" pitchFamily="34" charset="-120"/>
+                        </a:rPr>
+                        <a:t>0 무개입</a:t>
+                      </a:r>
+                      <a:endParaRPr lang="en-US" sz="1150" dirty="0">
+                        <a:latin typeface="Arial" charset="0"/>
+                        <a:ea typeface="Arial" charset="0"/>
+                        <a:cs typeface="Arial" charset="0"/>
+                      </a:endParaRPr>
+                    </a:p>
+                  </a:txBody>
+                  <a:tcPr marL="91440" marR="91440" marT="45720" marB="45720" anchor="ctr">
+                    <a:lnL w="9525" cap="flat" cmpd="sng" algn="ctr">
+                      <a:solidFill>
+                        <a:srgbClr val="E2E8F0"/>
+                      </a:solidFill>
+                      <a:prstDash val="solid"/>
+                      <a:round/>
+                      <a:headEnd type="none" w="med" len="med"/>
+                      <a:tailEnd type="none" w="med" len="med"/>
+                    </a:lnL>
+                    <a:lnR w="9525" cap="flat" cmpd="sng" algn="ctr">
+                      <a:solidFill>
+                        <a:srgbClr val="E2E8F0"/>
+                      </a:solidFill>
+                      <a:prstDash val="solid"/>
+                      <a:round/>
+                      <a:headEnd type="none" w="med" len="med"/>
+                      <a:tailEnd type="none" w="med" len="med"/>
+                    </a:lnR>
+                    <a:lnT w="9525" cap="flat" cmpd="sng" algn="ctr">
+                      <a:solidFill>
+                        <a:srgbClr val="E2E8F0"/>
+                      </a:solidFill>
+                      <a:prstDash val="solid"/>
+                      <a:round/>
+                      <a:headEnd type="none" w="med" len="med"/>
+                      <a:tailEnd type="none" w="med" len="med"/>
+                    </a:lnT>
+                    <a:lnB w="9525" cap="flat" cmpd="sng" algn="ctr">
+                      <a:solidFill>
+                        <a:srgbClr val="E2E8F0"/>
+                      </a:solidFill>
+                      <a:prstDash val="solid"/>
+                      <a:round/>
+                      <a:headEnd type="none" w="med" len="med"/>
+                      <a:tailEnd type="none" w="med" len="med"/>
+                    </a:lnB>
+                    <a:solidFill>
+                      <a:srgbClr val="1F3B57"/>
+                    </a:solidFill>
+                  </a:tcPr>
+                </a:tc>
+                <a:tc>
+                  <a:txBody>
+                    <a:bodyPr/>
+                    <a:lstStyle/>
+                    <a:p>
+                      <a:pPr algn="ctr" indent="0" marL="0">
+                        <a:buNone/>
+                      </a:pPr>
+                      <a:r>
+                        <a:rPr lang="en-US" sz="1150" b="1" dirty="0">
+                          <a:solidFill>
+                            <a:srgbClr val="FFFFFF"/>
+                          </a:solidFill>
+                          <a:latin typeface="Arial" pitchFamily="34" charset="0"/>
+                          <a:ea typeface="Arial" pitchFamily="34" charset="-122"/>
+                          <a:cs typeface="Arial" pitchFamily="34" charset="-120"/>
+                        </a:rPr>
+                        <a:t>1</a:t>
+                      </a:r>
+                      <a:endParaRPr lang="en-US" sz="1150" dirty="0">
+                        <a:latin typeface="Arial" charset="0"/>
+                        <a:ea typeface="Arial" charset="0"/>
+                        <a:cs typeface="Arial" charset="0"/>
+                      </a:endParaRPr>
+                    </a:p>
+                  </a:txBody>
+                  <a:tcPr marL="91440" marR="91440" marT="45720" marB="45720" anchor="ctr">
+                    <a:lnL w="9525" cap="flat" cmpd="sng" algn="ctr">
+                      <a:solidFill>
+                        <a:srgbClr val="E2E8F0"/>
+                      </a:solidFill>
+                      <a:prstDash val="solid"/>
+                      <a:round/>
+                      <a:headEnd type="none" w="med" len="med"/>
+                      <a:tailEnd type="none" w="med" len="med"/>
+                    </a:lnL>
+                    <a:lnR w="9525" cap="flat" cmpd="sng" algn="ctr">
+                      <a:solidFill>
+                        <a:srgbClr val="E2E8F0"/>
+                      </a:solidFill>
+                      <a:prstDash val="solid"/>
+                      <a:round/>
+                      <a:headEnd type="none" w="med" len="med"/>
+                      <a:tailEnd type="none" w="med" len="med"/>
+                    </a:lnR>
+                    <a:lnT w="9525" cap="flat" cmpd="sng" algn="ctr">
+                      <a:solidFill>
+                        <a:srgbClr val="E2E8F0"/>
+                      </a:solidFill>
+                      <a:prstDash val="solid"/>
+                      <a:round/>
+                      <a:headEnd type="none" w="med" len="med"/>
+                      <a:tailEnd type="none" w="med" len="med"/>
+                    </a:lnT>
+                    <a:lnB w="9525" cap="flat" cmpd="sng" algn="ctr">
+                      <a:solidFill>
+                        <a:srgbClr val="E2E8F0"/>
+                      </a:solidFill>
+                      <a:prstDash val="solid"/>
+                      <a:round/>
+                      <a:headEnd type="none" w="med" len="med"/>
+                      <a:tailEnd type="none" w="med" len="med"/>
+                    </a:lnB>
+                    <a:solidFill>
+                      <a:srgbClr val="1F3B57"/>
+                    </a:solidFill>
+                  </a:tcPr>
+                </a:tc>
+                <a:tc>
+                  <a:txBody>
+                    <a:bodyPr/>
+                    <a:lstStyle/>
+                    <a:p>
+                      <a:pPr algn="ctr" indent="0" marL="0">
+                        <a:buNone/>
+                      </a:pPr>
+                      <a:r>
+                        <a:rPr lang="en-US" sz="1150" b="1" dirty="0">
+                          <a:solidFill>
+                            <a:srgbClr val="FFFFFF"/>
+                          </a:solidFill>
+                          <a:latin typeface="Arial" pitchFamily="34" charset="0"/>
+                          <a:ea typeface="Arial" pitchFamily="34" charset="-122"/>
+                          <a:cs typeface="Arial" pitchFamily="34" charset="-120"/>
+                        </a:rPr>
+                        <a:t>2</a:t>
+                      </a:r>
+                      <a:endParaRPr lang="en-US" sz="1150" dirty="0">
+                        <a:latin typeface="Arial" charset="0"/>
+                        <a:ea typeface="Arial" charset="0"/>
+                        <a:cs typeface="Arial" charset="0"/>
+                      </a:endParaRPr>
+                    </a:p>
+                  </a:txBody>
+                  <a:tcPr marL="91440" marR="91440" marT="45720" marB="45720" anchor="ctr">
+                    <a:lnL w="9525" cap="flat" cmpd="sng" algn="ctr">
+                      <a:solidFill>
+                        <a:srgbClr val="E2E8F0"/>
+                      </a:solidFill>
+                      <a:prstDash val="solid"/>
+                      <a:round/>
+                      <a:headEnd type="none" w="med" len="med"/>
+                      <a:tailEnd type="none" w="med" len="med"/>
+                    </a:lnL>
+                    <a:lnR w="9525" cap="flat" cmpd="sng" algn="ctr">
+                      <a:solidFill>
+                        <a:srgbClr val="E2E8F0"/>
+                      </a:solidFill>
+                      <a:prstDash val="solid"/>
+                      <a:round/>
+                      <a:headEnd type="none" w="med" len="med"/>
+                      <a:tailEnd type="none" w="med" len="med"/>
+                    </a:lnR>
+                    <a:lnT w="9525" cap="flat" cmpd="sng" algn="ctr">
+                      <a:solidFill>
+                        <a:srgbClr val="E2E8F0"/>
+                      </a:solidFill>
+                      <a:prstDash val="solid"/>
+                      <a:round/>
+                      <a:headEnd type="none" w="med" len="med"/>
+                      <a:tailEnd type="none" w="med" len="med"/>
+                    </a:lnT>
+                    <a:lnB w="9525" cap="flat" cmpd="sng" algn="ctr">
+                      <a:solidFill>
+                        <a:srgbClr val="E2E8F0"/>
+                      </a:solidFill>
+                      <a:prstDash val="solid"/>
+                      <a:round/>
+                      <a:headEnd type="none" w="med" len="med"/>
+                      <a:tailEnd type="none" w="med" len="med"/>
+                    </a:lnB>
+                    <a:solidFill>
+                      <a:srgbClr val="1F3B57"/>
+                    </a:solidFill>
+                  </a:tcPr>
+                </a:tc>
+                <a:tc>
+                  <a:txBody>
+                    <a:bodyPr/>
+                    <a:lstStyle/>
+                    <a:p>
+                      <a:pPr algn="ctr" indent="0" marL="0">
+                        <a:buNone/>
+                      </a:pPr>
+                      <a:r>
+                        <a:rPr lang="en-US" sz="1150" b="1" dirty="0">
+                          <a:solidFill>
+                            <a:srgbClr val="FFFFFF"/>
+                          </a:solidFill>
+                          <a:latin typeface="Arial" pitchFamily="34" charset="0"/>
+                          <a:ea typeface="Arial" pitchFamily="34" charset="-122"/>
+                          <a:cs typeface="Arial" pitchFamily="34" charset="-120"/>
+                        </a:rPr>
+                        <a:t>4</a:t>
+                      </a:r>
+                      <a:endParaRPr lang="en-US" sz="1150" dirty="0">
+                        <a:latin typeface="Arial" charset="0"/>
+                        <a:ea typeface="Arial" charset="0"/>
+                        <a:cs typeface="Arial" charset="0"/>
+                      </a:endParaRPr>
+                    </a:p>
+                  </a:txBody>
+                  <a:tcPr marL="91440" marR="91440" marT="45720" marB="45720" anchor="ctr">
+                    <a:lnL w="9525" cap="flat" cmpd="sng" algn="ctr">
+                      <a:solidFill>
+                        <a:srgbClr val="E2E8F0"/>
+                      </a:solidFill>
+                      <a:prstDash val="solid"/>
+                      <a:round/>
+                      <a:headEnd type="none" w="med" len="med"/>
+                      <a:tailEnd type="none" w="med" len="med"/>
+                    </a:lnL>
+                    <a:lnR w="9525" cap="flat" cmpd="sng" algn="ctr">
+                      <a:solidFill>
+                        <a:srgbClr val="E2E8F0"/>
+                      </a:solidFill>
+                      <a:prstDash val="solid"/>
+                      <a:round/>
+                      <a:headEnd type="none" w="med" len="med"/>
+                      <a:tailEnd type="none" w="med" len="med"/>
+                    </a:lnR>
+                    <a:lnT w="9525" cap="flat" cmpd="sng" algn="ctr">
+                      <a:solidFill>
+                        <a:srgbClr val="E2E8F0"/>
+                      </a:solidFill>
+                      <a:prstDash val="solid"/>
+                      <a:round/>
+                      <a:headEnd type="none" w="med" len="med"/>
+                      <a:tailEnd type="none" w="med" len="med"/>
+                    </a:lnT>
+                    <a:lnB w="9525" cap="flat" cmpd="sng" algn="ctr">
+                      <a:solidFill>
+                        <a:srgbClr val="E2E8F0"/>
+                      </a:solidFill>
+                      <a:prstDash val="solid"/>
+                      <a:round/>
+                      <a:headEnd type="none" w="med" len="med"/>
+                      <a:tailEnd type="none" w="med" len="med"/>
+                    </a:lnB>
+                    <a:solidFill>
+                      <a:srgbClr val="1F3B57"/>
+                    </a:solidFill>
+                  </a:tcPr>
+                </a:tc>
+                <a:tc>
+                  <a:txBody>
+                    <a:bodyPr/>
+                    <a:lstStyle/>
+                    <a:p>
+                      <a:pPr algn="ctr" indent="0" marL="0">
+                        <a:buNone/>
+                      </a:pPr>
+                      <a:r>
+                        <a:rPr lang="en-US" sz="1150" b="1" dirty="0">
+                          <a:solidFill>
+                            <a:srgbClr val="FFFFFF"/>
+                          </a:solidFill>
+                          <a:latin typeface="Arial" pitchFamily="34" charset="0"/>
+                          <a:ea typeface="Arial" pitchFamily="34" charset="-122"/>
+                          <a:cs typeface="Arial" pitchFamily="34" charset="-120"/>
+                        </a:rPr>
+                        <a:t>8</a:t>
+                      </a:r>
+                      <a:endParaRPr lang="en-US" sz="1150" dirty="0">
+                        <a:latin typeface="Arial" charset="0"/>
+                        <a:ea typeface="Arial" charset="0"/>
+                        <a:cs typeface="Arial" charset="0"/>
+                      </a:endParaRPr>
+                    </a:p>
+                  </a:txBody>
+                  <a:tcPr marL="91440" marR="91440" marT="45720" marB="45720" anchor="ctr">
+                    <a:lnL w="9525" cap="flat" cmpd="sng" algn="ctr">
+                      <a:solidFill>
+                        <a:srgbClr val="E2E8F0"/>
+                      </a:solidFill>
+                      <a:prstDash val="solid"/>
+                      <a:round/>
+                      <a:headEnd type="none" w="med" len="med"/>
+                      <a:tailEnd type="none" w="med" len="med"/>
+                    </a:lnL>
+                    <a:lnR w="9525" cap="flat" cmpd="sng" algn="ctr">
+                      <a:solidFill>
+                        <a:srgbClr val="E2E8F0"/>
+                      </a:solidFill>
+                      <a:prstDash val="solid"/>
+                      <a:round/>
+                      <a:headEnd type="none" w="med" len="med"/>
+                      <a:tailEnd type="none" w="med" len="med"/>
+                    </a:lnR>
+                    <a:lnT w="9525" cap="flat" cmpd="sng" algn="ctr">
+                      <a:solidFill>
+                        <a:srgbClr val="E2E8F0"/>
+                      </a:solidFill>
+                      <a:prstDash val="solid"/>
+                      <a:round/>
+                      <a:headEnd type="none" w="med" len="med"/>
+                      <a:tailEnd type="none" w="med" len="med"/>
+                    </a:lnT>
+                    <a:lnB w="9525" cap="flat" cmpd="sng" algn="ctr">
+                      <a:solidFill>
+                        <a:srgbClr val="E2E8F0"/>
+                      </a:solidFill>
+                      <a:prstDash val="solid"/>
+                      <a:round/>
+                      <a:headEnd type="none" w="med" len="med"/>
+                      <a:tailEnd type="none" w="med" len="med"/>
+                    </a:lnB>
+                    <a:solidFill>
+                      <a:srgbClr val="1F3B57"/>
+                    </a:solidFill>
+                  </a:tcPr>
+                </a:tc>
+                <a:tc>
+                  <a:txBody>
+                    <a:bodyPr/>
+                    <a:lstStyle/>
+                    <a:p>
+                      <a:pPr algn="ctr" indent="0" marL="0">
+                        <a:buNone/>
+                      </a:pPr>
+                      <a:r>
+                        <a:rPr lang="en-US" sz="1150" b="1" dirty="0">
+                          <a:solidFill>
+                            <a:srgbClr val="FFFFFF"/>
+                          </a:solidFill>
+                          <a:latin typeface="Arial" pitchFamily="34" charset="0"/>
+                          <a:ea typeface="Arial" pitchFamily="34" charset="-122"/>
+                          <a:cs typeface="Arial" pitchFamily="34" charset="-120"/>
+                        </a:rPr>
+                        <a:t>∞ 하드</a:t>
+                      </a:r>
+                      <a:endParaRPr lang="en-US" sz="1150" dirty="0">
+                        <a:latin typeface="Arial" charset="0"/>
+                        <a:ea typeface="Arial" charset="0"/>
+                        <a:cs typeface="Arial" charset="0"/>
+                      </a:endParaRPr>
+                    </a:p>
+                  </a:txBody>
+                  <a:tcPr marL="91440" marR="91440" marT="45720" marB="45720" anchor="ctr">
+                    <a:lnL w="9525" cap="flat" cmpd="sng" algn="ctr">
+                      <a:solidFill>
+                        <a:srgbClr val="E2E8F0"/>
+                      </a:solidFill>
+                      <a:prstDash val="solid"/>
+                      <a:round/>
+                      <a:headEnd type="none" w="med" len="med"/>
+                      <a:tailEnd type="none" w="med" len="med"/>
+                    </a:lnL>
+                    <a:lnR w="9525" cap="flat" cmpd="sng" algn="ctr">
+                      <a:solidFill>
+                        <a:srgbClr val="E2E8F0"/>
+                      </a:solidFill>
+                      <a:prstDash val="solid"/>
+                      <a:round/>
+                      <a:headEnd type="none" w="med" len="med"/>
+                      <a:tailEnd type="none" w="med" len="med"/>
+                    </a:lnR>
+                    <a:lnT w="9525" cap="flat" cmpd="sng" algn="ctr">
+                      <a:solidFill>
+                        <a:srgbClr val="E2E8F0"/>
+                      </a:solidFill>
+                      <a:prstDash val="solid"/>
+                      <a:round/>
+                      <a:headEnd type="none" w="med" len="med"/>
+                      <a:tailEnd type="none" w="med" len="med"/>
+                    </a:lnT>
+                    <a:lnB w="9525" cap="flat" cmpd="sng" algn="ctr">
+                      <a:solidFill>
+                        <a:srgbClr val="E2E8F0"/>
+                      </a:solidFill>
+                      <a:prstDash val="solid"/>
+                      <a:round/>
+                      <a:headEnd type="none" w="med" len="med"/>
+                      <a:tailEnd type="none" w="med" len="med"/>
+                    </a:lnB>
+                    <a:solidFill>
+                      <a:srgbClr val="1F3B57"/>
+                    </a:solidFill>
+                  </a:tcPr>
+                </a:tc>
+              </a:tr>
+              <a:tr h="365760">
+                <a:tc>
+                  <a:txBody>
+                    <a:bodyPr/>
+                    <a:lstStyle/>
+                    <a:p>
+                      <a:pPr algn="ctr" indent="0" marL="0">
+                        <a:buNone/>
+                      </a:pPr>
+                      <a:r>
+                        <a:rPr lang="en-US" sz="1150" b="1" dirty="0">
+                          <a:solidFill>
+                            <a:srgbClr val="1F3B57"/>
+                          </a:solidFill>
+                          <a:latin typeface="Arial" pitchFamily="34" charset="0"/>
+                          <a:ea typeface="Arial" pitchFamily="34" charset="-122"/>
+                          <a:cs typeface="Arial" pitchFamily="34" charset="-120"/>
+                        </a:rPr>
+                        <a:t>AUC</a:t>
+                      </a:r>
+                      <a:endParaRPr lang="en-US" sz="1150" dirty="0">
+                        <a:latin typeface="Arial" charset="0"/>
+                        <a:ea typeface="Arial" charset="0"/>
+                        <a:cs typeface="Arial" charset="0"/>
+                      </a:endParaRPr>
+                    </a:p>
+                  </a:txBody>
+                  <a:tcPr marL="91440" marR="91440" marT="45720" marB="45720" anchor="ctr">
+                    <a:lnL w="9525" cap="flat" cmpd="sng" algn="ctr">
+                      <a:solidFill>
+                        <a:srgbClr val="E2E8F0"/>
+                      </a:solidFill>
+                      <a:prstDash val="solid"/>
+                      <a:round/>
+                      <a:headEnd type="none" w="med" len="med"/>
+                      <a:tailEnd type="none" w="med" len="med"/>
+                    </a:lnL>
+                    <a:lnR w="9525" cap="flat" cmpd="sng" algn="ctr">
+                      <a:solidFill>
+                        <a:srgbClr val="E2E8F0"/>
+                      </a:solidFill>
+                      <a:prstDash val="solid"/>
+                      <a:round/>
+                      <a:headEnd type="none" w="med" len="med"/>
+                      <a:tailEnd type="none" w="med" len="med"/>
+                    </a:lnR>
+                    <a:lnT w="9525" cap="flat" cmpd="sng" algn="ctr">
+                      <a:solidFill>
+                        <a:srgbClr val="E2E8F0"/>
+                      </a:solidFill>
+                      <a:prstDash val="solid"/>
+                      <a:round/>
+                      <a:headEnd type="none" w="med" len="med"/>
+                      <a:tailEnd type="none" w="med" len="med"/>
+                    </a:lnT>
+                    <a:lnB w="9525" cap="flat" cmpd="sng" algn="ctr">
+                      <a:solidFill>
+                        <a:srgbClr val="E2E8F0"/>
+                      </a:solidFill>
+                      <a:prstDash val="solid"/>
+                      <a:round/>
+                      <a:headEnd type="none" w="med" len="med"/>
+                      <a:tailEnd type="none" w="med" len="med"/>
+                    </a:lnB>
+                    <a:solidFill>
+                      <a:srgbClr val="FFFFFF"/>
+                    </a:solidFill>
+                  </a:tcPr>
+                </a:tc>
+                <a:tc>
+                  <a:txBody>
+                    <a:bodyPr/>
+                    <a:lstStyle/>
+                    <a:p>
+                      <a:pPr algn="ctr" indent="0" marL="0">
+                        <a:buNone/>
+                      </a:pPr>
+                      <a:r>
+                        <a:rPr lang="en-US" sz="1150" dirty="0">
+                          <a:solidFill>
+                            <a:srgbClr val="1F3B57"/>
+                          </a:solidFill>
+                          <a:latin typeface="Arial" pitchFamily="34" charset="0"/>
+                          <a:ea typeface="Arial" pitchFamily="34" charset="-122"/>
+                          <a:cs typeface="Arial" pitchFamily="34" charset="-120"/>
+                        </a:rPr>
+                        <a:t>0.6978</a:t>
+                      </a:r>
+                      <a:endParaRPr lang="en-US" sz="1150" dirty="0">
+                        <a:latin typeface="Arial" charset="0"/>
+                        <a:ea typeface="Arial" charset="0"/>
+                        <a:cs typeface="Arial" charset="0"/>
+                      </a:endParaRPr>
+                    </a:p>
+                  </a:txBody>
+                  <a:tcPr marL="91440" marR="91440" marT="45720" marB="45720" anchor="ctr">
+                    <a:lnL w="9525" cap="flat" cmpd="sng" algn="ctr">
+                      <a:solidFill>
+                        <a:srgbClr val="E2E8F0"/>
+                      </a:solidFill>
+                      <a:prstDash val="solid"/>
+                      <a:round/>
+                      <a:headEnd type="none" w="med" len="med"/>
+                      <a:tailEnd type="none" w="med" len="med"/>
+                    </a:lnL>
+                    <a:lnR w="9525" cap="flat" cmpd="sng" algn="ctr">
+                      <a:solidFill>
+                        <a:srgbClr val="E2E8F0"/>
+                      </a:solidFill>
+                      <a:prstDash val="solid"/>
+                      <a:round/>
+                      <a:headEnd type="none" w="med" len="med"/>
+                      <a:tailEnd type="none" w="med" len="med"/>
+                    </a:lnR>
+                    <a:lnT w="9525" cap="flat" cmpd="sng" algn="ctr">
+                      <a:solidFill>
+                        <a:srgbClr val="E2E8F0"/>
+                      </a:solidFill>
+                      <a:prstDash val="solid"/>
+                      <a:round/>
+                      <a:headEnd type="none" w="med" len="med"/>
+                      <a:tailEnd type="none" w="med" len="med"/>
+                    </a:lnT>
+                    <a:lnB w="9525" cap="flat" cmpd="sng" algn="ctr">
+                      <a:solidFill>
+                        <a:srgbClr val="E2E8F0"/>
+                      </a:solidFill>
+                      <a:prstDash val="solid"/>
+                      <a:round/>
+                      <a:headEnd type="none" w="med" len="med"/>
+                      <a:tailEnd type="none" w="med" len="med"/>
+                    </a:lnB>
+                    <a:solidFill>
+                      <a:srgbClr val="FFFFFF"/>
+                    </a:solidFill>
+                  </a:tcPr>
+                </a:tc>
+                <a:tc>
+                  <a:txBody>
+                    <a:bodyPr/>
+                    <a:lstStyle/>
+                    <a:p>
+                      <a:pPr algn="ctr" indent="0" marL="0">
+                        <a:buNone/>
+                      </a:pPr>
+                      <a:r>
+                        <a:rPr lang="en-US" sz="1150" dirty="0">
+                          <a:solidFill>
+                            <a:srgbClr val="1F3B57"/>
+                          </a:solidFill>
+                          <a:latin typeface="Arial" pitchFamily="34" charset="0"/>
+                          <a:ea typeface="Arial" pitchFamily="34" charset="-122"/>
+                          <a:cs typeface="Arial" pitchFamily="34" charset="-120"/>
+                        </a:rPr>
+                        <a:t>0.7729</a:t>
+                      </a:r>
+                      <a:endParaRPr lang="en-US" sz="1150" dirty="0">
+                        <a:latin typeface="Arial" charset="0"/>
+                        <a:ea typeface="Arial" charset="0"/>
+                        <a:cs typeface="Arial" charset="0"/>
+                      </a:endParaRPr>
+                    </a:p>
+                  </a:txBody>
+                  <a:tcPr marL="91440" marR="91440" marT="45720" marB="45720" anchor="ctr">
+                    <a:lnL w="9525" cap="flat" cmpd="sng" algn="ctr">
+                      <a:solidFill>
+                        <a:srgbClr val="E2E8F0"/>
+                      </a:solidFill>
+                      <a:prstDash val="solid"/>
+                      <a:round/>
+                      <a:headEnd type="none" w="med" len="med"/>
+                      <a:tailEnd type="none" w="med" len="med"/>
+                    </a:lnL>
+                    <a:lnR w="9525" cap="flat" cmpd="sng" algn="ctr">
+                      <a:solidFill>
+                        <a:srgbClr val="E2E8F0"/>
+                      </a:solidFill>
+                      <a:prstDash val="solid"/>
+                      <a:round/>
+                      <a:headEnd type="none" w="med" len="med"/>
+                      <a:tailEnd type="none" w="med" len="med"/>
+                    </a:lnR>
+                    <a:lnT w="9525" cap="flat" cmpd="sng" algn="ctr">
+                      <a:solidFill>
+                        <a:srgbClr val="E2E8F0"/>
+                      </a:solidFill>
+                      <a:prstDash val="solid"/>
+                      <a:round/>
+                      <a:headEnd type="none" w="med" len="med"/>
+                      <a:tailEnd type="none" w="med" len="med"/>
+                    </a:lnT>
+                    <a:lnB w="9525" cap="flat" cmpd="sng" algn="ctr">
+                      <a:solidFill>
+                        <a:srgbClr val="E2E8F0"/>
+                      </a:solidFill>
+                      <a:prstDash val="solid"/>
+                      <a:round/>
+                      <a:headEnd type="none" w="med" len="med"/>
+                      <a:tailEnd type="none" w="med" len="med"/>
+                    </a:lnB>
+                    <a:solidFill>
+                      <a:srgbClr val="FFFFFF"/>
+                    </a:solidFill>
+                  </a:tcPr>
+                </a:tc>
+                <a:tc>
+                  <a:txBody>
+                    <a:bodyPr/>
+                    <a:lstStyle/>
+                    <a:p>
+                      <a:pPr algn="ctr" indent="0" marL="0">
+                        <a:buNone/>
+                      </a:pPr>
+                      <a:r>
+                        <a:rPr lang="en-US" sz="1150" dirty="0">
+                          <a:solidFill>
+                            <a:srgbClr val="1F3B57"/>
+                          </a:solidFill>
+                          <a:latin typeface="Arial" pitchFamily="34" charset="0"/>
+                          <a:ea typeface="Arial" pitchFamily="34" charset="-122"/>
+                          <a:cs typeface="Arial" pitchFamily="34" charset="-120"/>
+                        </a:rPr>
+                        <a:t>0.8092</a:t>
+                      </a:r>
+                      <a:endParaRPr lang="en-US" sz="1150" dirty="0">
+                        <a:latin typeface="Arial" charset="0"/>
+                        <a:ea typeface="Arial" charset="0"/>
+                        <a:cs typeface="Arial" charset="0"/>
+                      </a:endParaRPr>
+                    </a:p>
+                  </a:txBody>
+                  <a:tcPr marL="91440" marR="91440" marT="45720" marB="45720" anchor="ctr">
+                    <a:lnL w="9525" cap="flat" cmpd="sng" algn="ctr">
+                      <a:solidFill>
+                        <a:srgbClr val="E2E8F0"/>
+                      </a:solidFill>
+                      <a:prstDash val="solid"/>
+                      <a:round/>
+                      <a:headEnd type="none" w="med" len="med"/>
+                      <a:tailEnd type="none" w="med" len="med"/>
+                    </a:lnL>
+                    <a:lnR w="9525" cap="flat" cmpd="sng" algn="ctr">
+                      <a:solidFill>
+                        <a:srgbClr val="E2E8F0"/>
+                      </a:solidFill>
+                      <a:prstDash val="solid"/>
+                      <a:round/>
+                      <a:headEnd type="none" w="med" len="med"/>
+                      <a:tailEnd type="none" w="med" len="med"/>
+                    </a:lnR>
+                    <a:lnT w="9525" cap="flat" cmpd="sng" algn="ctr">
+                      <a:solidFill>
+                        <a:srgbClr val="E2E8F0"/>
+                      </a:solidFill>
+                      <a:prstDash val="solid"/>
+                      <a:round/>
+                      <a:headEnd type="none" w="med" len="med"/>
+                      <a:tailEnd type="none" w="med" len="med"/>
+                    </a:lnT>
+                    <a:lnB w="9525" cap="flat" cmpd="sng" algn="ctr">
+                      <a:solidFill>
+                        <a:srgbClr val="E2E8F0"/>
+                      </a:solidFill>
+                      <a:prstDash val="solid"/>
+                      <a:round/>
+                      <a:headEnd type="none" w="med" len="med"/>
+                      <a:tailEnd type="none" w="med" len="med"/>
+                    </a:lnB>
+                    <a:solidFill>
+                      <a:srgbClr val="FFFFFF"/>
+                    </a:solidFill>
+                  </a:tcPr>
+                </a:tc>
+                <a:tc>
+                  <a:txBody>
+                    <a:bodyPr/>
+                    <a:lstStyle/>
+                    <a:p>
+                      <a:pPr algn="ctr" indent="0" marL="0">
+                        <a:buNone/>
+                      </a:pPr>
+                      <a:r>
+                        <a:rPr lang="en-US" sz="1150" dirty="0">
+                          <a:solidFill>
+                            <a:srgbClr val="1F3B57"/>
+                          </a:solidFill>
+                          <a:latin typeface="Arial" pitchFamily="34" charset="0"/>
+                          <a:ea typeface="Arial" pitchFamily="34" charset="-122"/>
+                          <a:cs typeface="Arial" pitchFamily="34" charset="-120"/>
+                        </a:rPr>
+                        <a:t>0.8513</a:t>
+                      </a:r>
+                      <a:endParaRPr lang="en-US" sz="1150" dirty="0">
+                        <a:latin typeface="Arial" charset="0"/>
+                        <a:ea typeface="Arial" charset="0"/>
+                        <a:cs typeface="Arial" charset="0"/>
+                      </a:endParaRPr>
+                    </a:p>
+                  </a:txBody>
+                  <a:tcPr marL="91440" marR="91440" marT="45720" marB="45720" anchor="ctr">
+                    <a:lnL w="9525" cap="flat" cmpd="sng" algn="ctr">
+                      <a:solidFill>
+                        <a:srgbClr val="E2E8F0"/>
+                      </a:solidFill>
+                      <a:prstDash val="solid"/>
+                      <a:round/>
+                      <a:headEnd type="none" w="med" len="med"/>
+                      <a:tailEnd type="none" w="med" len="med"/>
+                    </a:lnL>
+                    <a:lnR w="9525" cap="flat" cmpd="sng" algn="ctr">
+                      <a:solidFill>
+                        <a:srgbClr val="E2E8F0"/>
+                      </a:solidFill>
+                      <a:prstDash val="solid"/>
+                      <a:round/>
+                      <a:headEnd type="none" w="med" len="med"/>
+                      <a:tailEnd type="none" w="med" len="med"/>
+                    </a:lnR>
+                    <a:lnT w="9525" cap="flat" cmpd="sng" algn="ctr">
+                      <a:solidFill>
+                        <a:srgbClr val="E2E8F0"/>
+                      </a:solidFill>
+                      <a:prstDash val="solid"/>
+                      <a:round/>
+                      <a:headEnd type="none" w="med" len="med"/>
+                      <a:tailEnd type="none" w="med" len="med"/>
+                    </a:lnT>
+                    <a:lnB w="9525" cap="flat" cmpd="sng" algn="ctr">
+                      <a:solidFill>
+                        <a:srgbClr val="E2E8F0"/>
+                      </a:solidFill>
+                      <a:prstDash val="solid"/>
+                      <a:round/>
+                      <a:headEnd type="none" w="med" len="med"/>
+                      <a:tailEnd type="none" w="med" len="med"/>
+                    </a:lnB>
+                    <a:solidFill>
+                      <a:srgbClr val="FFFFFF"/>
+                    </a:solidFill>
+                  </a:tcPr>
+                </a:tc>
+                <a:tc>
+                  <a:txBody>
+                    <a:bodyPr/>
+                    <a:lstStyle/>
+                    <a:p>
+                      <a:pPr algn="ctr" indent="0" marL="0">
+                        <a:buNone/>
+                      </a:pPr>
+                      <a:r>
+                        <a:rPr lang="en-US" sz="1150" dirty="0">
+                          <a:solidFill>
+                            <a:srgbClr val="1F3B57"/>
+                          </a:solidFill>
+                          <a:latin typeface="Arial" pitchFamily="34" charset="0"/>
+                          <a:ea typeface="Arial" pitchFamily="34" charset="-122"/>
+                          <a:cs typeface="Arial" pitchFamily="34" charset="-120"/>
+                        </a:rPr>
+                        <a:t>0.9036</a:t>
+                      </a:r>
+                      <a:endParaRPr lang="en-US" sz="1150" dirty="0">
+                        <a:latin typeface="Arial" charset="0"/>
+                        <a:ea typeface="Arial" charset="0"/>
+                        <a:cs typeface="Arial" charset="0"/>
+                      </a:endParaRPr>
+                    </a:p>
+                  </a:txBody>
+                  <a:tcPr marL="91440" marR="91440" marT="45720" marB="45720" anchor="ctr">
+                    <a:lnL w="9525" cap="flat" cmpd="sng" algn="ctr">
+                      <a:solidFill>
+                        <a:srgbClr val="E2E8F0"/>
+                      </a:solidFill>
+                      <a:prstDash val="solid"/>
+                      <a:round/>
+                      <a:headEnd type="none" w="med" len="med"/>
+                      <a:tailEnd type="none" w="med" len="med"/>
+                    </a:lnL>
+                    <a:lnR w="9525" cap="flat" cmpd="sng" algn="ctr">
+                      <a:solidFill>
+                        <a:srgbClr val="E2E8F0"/>
+                      </a:solidFill>
+                      <a:prstDash val="solid"/>
+                      <a:round/>
+                      <a:headEnd type="none" w="med" len="med"/>
+                      <a:tailEnd type="none" w="med" len="med"/>
+                    </a:lnR>
+                    <a:lnT w="9525" cap="flat" cmpd="sng" algn="ctr">
+                      <a:solidFill>
+                        <a:srgbClr val="E2E8F0"/>
+                      </a:solidFill>
+                      <a:prstDash val="solid"/>
+                      <a:round/>
+                      <a:headEnd type="none" w="med" len="med"/>
+                      <a:tailEnd type="none" w="med" len="med"/>
+                    </a:lnT>
+                    <a:lnB w="9525" cap="flat" cmpd="sng" algn="ctr">
+                      <a:solidFill>
+                        <a:srgbClr val="E2E8F0"/>
+                      </a:solidFill>
+                      <a:prstDash val="solid"/>
+                      <a:round/>
+                      <a:headEnd type="none" w="med" len="med"/>
+                      <a:tailEnd type="none" w="med" len="med"/>
+                    </a:lnB>
+                    <a:solidFill>
+                      <a:srgbClr val="FFFFFF"/>
+                    </a:solidFill>
+                  </a:tcPr>
+                </a:tc>
+                <a:tc>
+                  <a:txBody>
+                    <a:bodyPr/>
+                    <a:lstStyle/>
+                    <a:p>
+                      <a:pPr algn="ctr" indent="0" marL="0">
+                        <a:buNone/>
+                      </a:pPr>
+                      <a:r>
+                        <a:rPr lang="en-US" sz="1150" b="1" dirty="0">
+                          <a:solidFill>
+                            <a:srgbClr val="1F3B57"/>
+                          </a:solidFill>
+                          <a:latin typeface="Arial" pitchFamily="34" charset="0"/>
+                          <a:ea typeface="Arial" pitchFamily="34" charset="-122"/>
+                          <a:cs typeface="Arial" pitchFamily="34" charset="-120"/>
+                        </a:rPr>
+                        <a:t>0.9058</a:t>
+                      </a:r>
+                      <a:endParaRPr lang="en-US" sz="1150" dirty="0">
+                        <a:latin typeface="Arial" charset="0"/>
+                        <a:ea typeface="Arial" charset="0"/>
+                        <a:cs typeface="Arial" charset="0"/>
+                      </a:endParaRPr>
+                    </a:p>
+                  </a:txBody>
+                  <a:tcPr marL="91440" marR="91440" marT="45720" marB="45720" anchor="ctr">
+                    <a:lnL w="9525" cap="flat" cmpd="sng" algn="ctr">
+                      <a:solidFill>
+                        <a:srgbClr val="E2E8F0"/>
+                      </a:solidFill>
+                      <a:prstDash val="solid"/>
+                      <a:round/>
+                      <a:headEnd type="none" w="med" len="med"/>
+                      <a:tailEnd type="none" w="med" len="med"/>
+                    </a:lnL>
+                    <a:lnR w="9525" cap="flat" cmpd="sng" algn="ctr">
+                      <a:solidFill>
+                        <a:srgbClr val="E2E8F0"/>
+                      </a:solidFill>
+                      <a:prstDash val="solid"/>
+                      <a:round/>
+                      <a:headEnd type="none" w="med" len="med"/>
+                      <a:tailEnd type="none" w="med" len="med"/>
+                    </a:lnR>
+                    <a:lnT w="9525" cap="flat" cmpd="sng" algn="ctr">
+                      <a:solidFill>
+                        <a:srgbClr val="E2E8F0"/>
+                      </a:solidFill>
+                      <a:prstDash val="solid"/>
+                      <a:round/>
+                      <a:headEnd type="none" w="med" len="med"/>
+                      <a:tailEnd type="none" w="med" len="med"/>
+                    </a:lnT>
+                    <a:lnB w="9525" cap="flat" cmpd="sng" algn="ctr">
+                      <a:solidFill>
+                        <a:srgbClr val="E2E8F0"/>
+                      </a:solidFill>
+                      <a:prstDash val="solid"/>
+                      <a:round/>
+                      <a:headEnd type="none" w="med" len="med"/>
+                      <a:tailEnd type="none" w="med" len="med"/>
+                    </a:lnB>
+                    <a:solidFill>
+                      <a:srgbClr val="FFFFFF"/>
+                    </a:solidFill>
+                  </a:tcPr>
+                </a:tc>
+              </a:tr>
+            </a:tbl>
+          </a:graphicData>
+        </a:graphic>
+      </p:graphicFrame>
+      <p:sp>
+        <p:nvSpPr>
+          <p:cNvPr id="7" name="Text 3"/>
+          <p:cNvSpPr/>
+          <p:nvPr/>
+        </p:nvSpPr>
+        <p:spPr>
+          <a:xfrm>
+            <a:off x="502920" y="4718304"/>
+            <a:ext cx="11201400" cy="274320"/>
+          </a:xfrm>
+          <a:prstGeom prst="rect">
+            <a:avLst/>
+          </a:prstGeom>
+          <a:noFill/>
+          <a:ln/>
+        </p:spPr>
+        <p:txBody>
+          <a:bodyPr wrap="square" lIns="0" tIns="0" rIns="0" bIns="0" rtlCol="0" anchor="ctr"/>
+          <a:lstStyle/>
+          <a:p>
+            <a:pPr indent="0" marL="0">
+              <a:buNone/>
+            </a:pPr>
+            <a:r>
+              <a:rPr lang="en-US" sz="1100" dirty="0">
+                <a:solidFill>
+                  <a:srgbClr val="6B7280"/>
+                </a:solidFill>
+                <a:latin typeface="Arial" pitchFamily="34" charset="0"/>
+                <a:ea typeface="Arial" pitchFamily="34" charset="-122"/>
+                <a:cs typeface="Arial" pitchFamily="34" charset="-120"/>
+              </a:rPr>
+              <a:t>λ=4만 줘도 손상의 74%를 회수합니다. selector의 오판은 AUC 0.015~0.043으로 복구 불가지만, 개입은 강도를 낮춰 비용을 비례적으로 줄일 수 있습니다.</a:t>
+            </a:r>
+            <a:endParaRPr lang="en-US" sz="1100" dirty="0"/>
+          </a:p>
+        </p:txBody>
+      </p:sp>
+      <p:sp>
+        <p:nvSpPr>
+          <p:cNvPr id="8" name="Shape 4"/>
+          <p:cNvSpPr/>
+          <p:nvPr/>
+        </p:nvSpPr>
+        <p:spPr>
+          <a:xfrm>
+            <a:off x="502920" y="5047488"/>
+            <a:ext cx="11201400" cy="914400"/>
           </a:xfrm>
           <a:prstGeom prst="roundRect">
             <a:avLst>
-              <a:gd name="adj" fmla="val 4865"/>
+              <a:gd name="adj" fmla="val 9000"/>
             </a:avLst>
           </a:prstGeom>
           <a:solidFill>
@@ -19088,13 +20431,13 @@
       </p:sp>
       <p:sp>
         <p:nvSpPr>
-          <p:cNvPr id="6" name="Text 3"/>
+          <p:cNvPr id="9" name="Text 5"/>
           <p:cNvSpPr/>
           <p:nvPr/>
         </p:nvSpPr>
         <p:spPr>
           <a:xfrm>
-            <a:off x="777240" y="3986784"/>
+            <a:off x="777240" y="5138928"/>
             <a:ext cx="10698480" cy="274320"/>
           </a:xfrm>
           <a:prstGeom prst="rect">
@@ -19127,14 +20470,14 @@
       </p:sp>
       <p:sp>
         <p:nvSpPr>
-          <p:cNvPr id="7" name="Text 4"/>
+          <p:cNvPr id="10" name="Text 6"/>
           <p:cNvSpPr/>
           <p:nvPr/>
         </p:nvSpPr>
         <p:spPr>
           <a:xfrm>
-            <a:off x="777240" y="4334256"/>
-            <a:ext cx="10698480" cy="1097280"/>
+            <a:off x="777240" y="5449824"/>
+            <a:ext cx="10698480" cy="420624"/>
           </a:xfrm>
           <a:prstGeom prst="rect">
             <a:avLst/>
@@ -19147,13 +20490,10 @@
           <a:lstStyle/>
           <a:p>
             <a:pPr indent="0" marL="0">
-              <a:spcAft>
-                <a:spcPts val="600"/>
-              </a:spcAft>
               <a:buNone/>
             </a:pPr>
             <a:r>
-              <a:rPr lang="en-US" sz="1150" dirty="0">
+              <a:rPr lang="en-US" sz="1100" dirty="0">
                 <a:solidFill>
                   <a:srgbClr val="1F3B57"/>
                 </a:solidFill>
@@ -19161,35 +20501,15 @@
                 <a:ea typeface="Arial" pitchFamily="34" charset="-122"/>
                 <a:cs typeface="Arial" pitchFamily="34" charset="-120"/>
               </a:rPr>
-              <a:t>margin_CD = (1+β)·margin(차단) − β·margin(무개입).  두 끝점을 빼기만 한 '차이 신호'도 단독으로 AUC 0.9370입니다 — 차단본(0.9041)보다도 높습니다.</a:t>
+              <a:t>두 끝점을 빼기만 한 '차이 신호'도 단독으로 AUC 0.9370 — 차단본(0.9041)보다 높습니다. 방해가 답을 많이 밀어낸 문항이 곧 틀릴 뻔한 문항이기 때문입니다.</a:t>
             </a:r>
-            <a:endParaRPr lang="en-US" sz="1150" dirty="0"/>
-          </a:p>
-          <a:p>
-            <a:pPr indent="0" marL="0">
-              <a:spcAft>
-                <a:spcPts val="600"/>
-              </a:spcAft>
-              <a:buNone/>
-            </a:pPr>
-            <a:r>
-              <a:rPr lang="en-US" sz="1150" dirty="0">
-                <a:solidFill>
-                  <a:srgbClr val="1F3B57"/>
-                </a:solidFill>
-                <a:latin typeface="Arial" pitchFamily="34" charset="0"/>
-                <a:ea typeface="Arial" pitchFamily="34" charset="-122"/>
-                <a:cs typeface="Arial" pitchFamily="34" charset="-120"/>
-              </a:rPr>
-              <a:t>방해 이미지가 답을 많이 밀어낸 문항이 곧 틀릴 뻔한 문항이기 때문입니다. 제거는 오염을 없애고, 대조는 오염의 크기를 정보로 씁니다. 7B에서는 지울 오염이 적어 β를 키우면 오히려 손해입니다 (β=2에서 0.828).</a:t>
-            </a:r>
-            <a:endParaRPr lang="en-US" sz="1150" dirty="0"/>
+            <a:endParaRPr lang="en-US" sz="1100" dirty="0"/>
           </a:p>
         </p:txBody>
       </p:sp>
       <p:sp>
         <p:nvSpPr>
-          <p:cNvPr id="8" name="Shape 5"/>
+          <p:cNvPr id="11" name="Shape 7"/>
           <p:cNvSpPr/>
           <p:nvPr/>
         </p:nvSpPr>
@@ -19211,7 +20531,7 @@
       </p:sp>
       <p:sp>
         <p:nvSpPr>
-          <p:cNvPr id="9" name="Text 6"/>
+          <p:cNvPr id="12" name="Text 8"/>
           <p:cNvSpPr/>
           <p:nvPr/>
         </p:nvSpPr>

</xml_diff>

<commit_message>
CLIP selector head-to-head: semantic similarity is at chance, and says why
Same items, same N. CLIP scores 0.51/0.39/0.33 against random 0.50/0.33/0.25 on
both the question sentence and the bare object name — the friendlier prompt — while
the counterfactual controller reaches 0.69/0.71/0.73. The reason is structural:
cell 1 puts the queried object in the distractor, so picking the image most
semantically similar to the object picks the distractor. A semantic selector fails
precisely in the cases where contamination happens.

Recorded with its limit stated: our questions name the target by position, so a
text-parsing selector would score 100%. This shows semantic selection fails, not
that every front-end module fails, and slide 5's footnote now says so.

Co-Authored-By: Claude Fable 5 <noreply@anthropic.com>
</commit_message>
<xml_diff>
--- a/meeting/SourceDepth_meeting_v5.pptx
+++ b/meeting/SourceDepth_meeting_v5.pptx
@@ -10949,7 +10949,7 @@
                 <a:ea typeface="Arial" pitchFamily="34" charset="-122"/>
                 <a:cs typeface="Arial" pitchFamily="34" charset="-120"/>
               </a:rPr>
-              <a:t>게다가 selector가 틀려서 관련 이미지를 버리면 AUC가 0.015~0.043으로 붕괴합니다 — 복구 불가능한 오류입니다. 모델 내부 개입은 층·경로·강도를 연속적으로 조절할 수 있습니다.</a:t>
+              <a:t>실제로 CLIP selector는 우연 수준입니다 (N=1·2·3에서 0.51 / 0.39 / 0.33, 무작위 0.50 / 0.33 / 0.25). 방해 이미지가 질의 객체를 담고 있으면 의미 유사도는 오히려 방해 쪽을 고릅니다 — 오염이 일어나는 바로 그 상황에서 틀립니다. 같은 문항에서 반사실 컨트롤러는 0.69 / 0.71 / 0.73입니다.</a:t>
             </a:r>
             <a:endParaRPr lang="en-US" sz="1150" dirty="0"/>
           </a:p>
@@ -10988,7 +10988,7 @@
                 <a:ea typeface="Arial" pitchFamily="34" charset="-122"/>
                 <a:cs typeface="Arial" pitchFamily="34" charset="-120"/>
               </a:rPr>
-              <a:t>all-of-3에서는 어떤 이미지도 버릴 수 없다는 것이 설계상 자명하며, 이는 고립 비용과 무관하게 성립합니다</a:t>
+              <a:t>단, 현 벤치마크는 관련도를 위치로 정의하므로 텍스트를 파싱하는 selector는 100%입니다 — 이 비교는 '의미 유사도로는 안 된다'까지만 보입니다 (슬라이드 9 한계①)</a:t>
             </a:r>
             <a:endParaRPr lang="en-US" sz="1000" dirty="0"/>
           </a:p>

</xml_diff>